<commit_message>
update network-anomaly-architecture-semantics-lifecycle slide deck
</commit_message>
<xml_diff>
--- a/125/NMOP/draft-ietf-nmop-network-anomaly-architecture-semantics-lifecycle.pptx
+++ b/125/NMOP/draft-ietf-nmop-network-anomaly-architecture-semantics-lifecycle.pptx
@@ -143,93 +143,30 @@
 </p:presentation>
 </file>
 
-<file path=ppt/changesInfos/changesInfo1.xml><?xml version="1.0" encoding="utf-8"?>
-<pc:chgInfo xmlns:a="http://schemas.openxmlformats.org/drawingml/2006/main" xmlns:r="http://schemas.openxmlformats.org/officeDocument/2006/relationships" xmlns:ac="http://schemas.microsoft.com/office/drawing/2013/main/command" xmlns:pc="http://schemas.microsoft.com/office/powerpoint/2013/main/command">
-  <pc:docChgLst>
-    <pc:chgData name="Graf Thomas, SCS-INI-NET-VNC-E2E" userId="487bc3e3-9ce7-4cdd-b7b4-8899ea88d289" providerId="ADAL" clId="{ADEEF08A-D719-4B50-A383-4105EDA2C206}"/>
-    <pc:docChg chg="custSel delSld modSld">
-      <pc:chgData name="Graf Thomas, SCS-INI-NET-VNC-E2E" userId="487bc3e3-9ce7-4cdd-b7b4-8899ea88d289" providerId="ADAL" clId="{ADEEF08A-D719-4B50-A383-4105EDA2C206}" dt="2026-03-06T15:43:07.950" v="18" actId="108"/>
-      <pc:docMkLst>
-        <pc:docMk/>
-      </pc:docMkLst>
-      <pc:sldChg chg="modSp mod">
-        <pc:chgData name="Graf Thomas, SCS-INI-NET-VNC-E2E" userId="487bc3e3-9ce7-4cdd-b7b4-8899ea88d289" providerId="ADAL" clId="{ADEEF08A-D719-4B50-A383-4105EDA2C206}" dt="2026-03-06T15:39:40.573" v="1" actId="20577"/>
-        <pc:sldMkLst>
-          <pc:docMk/>
-          <pc:sldMk cId="3476293507" sldId="2145706306"/>
-        </pc:sldMkLst>
-        <pc:spChg chg="mod">
-          <ac:chgData name="Graf Thomas, SCS-INI-NET-VNC-E2E" userId="487bc3e3-9ce7-4cdd-b7b4-8899ea88d289" providerId="ADAL" clId="{ADEEF08A-D719-4B50-A383-4105EDA2C206}" dt="2026-03-06T15:39:40.573" v="1" actId="20577"/>
-          <ac:spMkLst>
-            <pc:docMk/>
-            <pc:sldMk cId="3476293507" sldId="2145706306"/>
-            <ac:spMk id="2" creationId="{3219CA57-C4F2-8E12-EB3C-B9496482903B}"/>
-          </ac:spMkLst>
-        </pc:spChg>
-        <pc:spChg chg="mod">
-          <ac:chgData name="Graf Thomas, SCS-INI-NET-VNC-E2E" userId="487bc3e3-9ce7-4cdd-b7b4-8899ea88d289" providerId="ADAL" clId="{ADEEF08A-D719-4B50-A383-4105EDA2C206}" dt="2026-03-06T15:39:22.444" v="0" actId="313"/>
-          <ac:spMkLst>
-            <pc:docMk/>
-            <pc:sldMk cId="3476293507" sldId="2145706306"/>
-            <ac:spMk id="3" creationId="{AA209B5F-12F6-9A75-A5C8-FB699F15D6EB}"/>
-          </ac:spMkLst>
-        </pc:spChg>
-      </pc:sldChg>
-      <pc:sldChg chg="modSp mod">
-        <pc:chgData name="Graf Thomas, SCS-INI-NET-VNC-E2E" userId="487bc3e3-9ce7-4cdd-b7b4-8899ea88d289" providerId="ADAL" clId="{ADEEF08A-D719-4B50-A383-4105EDA2C206}" dt="2026-03-06T15:41:32.132" v="2" actId="20577"/>
-        <pc:sldMkLst>
-          <pc:docMk/>
-          <pc:sldMk cId="3767000517" sldId="2145706307"/>
-        </pc:sldMkLst>
-        <pc:spChg chg="mod">
-          <ac:chgData name="Graf Thomas, SCS-INI-NET-VNC-E2E" userId="487bc3e3-9ce7-4cdd-b7b4-8899ea88d289" providerId="ADAL" clId="{ADEEF08A-D719-4B50-A383-4105EDA2C206}" dt="2026-03-06T15:41:32.132" v="2" actId="20577"/>
-          <ac:spMkLst>
-            <pc:docMk/>
-            <pc:sldMk cId="3767000517" sldId="2145706307"/>
-            <ac:spMk id="2" creationId="{D089D996-32CC-F1DF-7AF4-6649A3C8B347}"/>
-          </ac:spMkLst>
-        </pc:spChg>
-      </pc:sldChg>
-      <pc:sldChg chg="modSp mod">
-        <pc:chgData name="Graf Thomas, SCS-INI-NET-VNC-E2E" userId="487bc3e3-9ce7-4cdd-b7b4-8899ea88d289" providerId="ADAL" clId="{ADEEF08A-D719-4B50-A383-4105EDA2C206}" dt="2026-03-06T15:41:55.583" v="3" actId="20577"/>
-        <pc:sldMkLst>
-          <pc:docMk/>
-          <pc:sldMk cId="1375384195" sldId="2145706308"/>
-        </pc:sldMkLst>
-        <pc:spChg chg="mod">
-          <ac:chgData name="Graf Thomas, SCS-INI-NET-VNC-E2E" userId="487bc3e3-9ce7-4cdd-b7b4-8899ea88d289" providerId="ADAL" clId="{ADEEF08A-D719-4B50-A383-4105EDA2C206}" dt="2026-03-06T15:41:55.583" v="3" actId="20577"/>
-          <ac:spMkLst>
-            <pc:docMk/>
-            <pc:sldMk cId="1375384195" sldId="2145706308"/>
-            <ac:spMk id="2" creationId="{FB1E4305-F060-2A08-29F5-1983A414A45C}"/>
-          </ac:spMkLst>
-        </pc:spChg>
-      </pc:sldChg>
-      <pc:sldChg chg="del">
-        <pc:chgData name="Graf Thomas, SCS-INI-NET-VNC-E2E" userId="487bc3e3-9ce7-4cdd-b7b4-8899ea88d289" providerId="ADAL" clId="{ADEEF08A-D719-4B50-A383-4105EDA2C206}" dt="2026-03-06T15:41:58.605" v="4" actId="47"/>
-        <pc:sldMkLst>
-          <pc:docMk/>
-          <pc:sldMk cId="2179103081" sldId="2145706311"/>
-        </pc:sldMkLst>
-      </pc:sldChg>
-      <pc:sldChg chg="modSp mod">
-        <pc:chgData name="Graf Thomas, SCS-INI-NET-VNC-E2E" userId="487bc3e3-9ce7-4cdd-b7b4-8899ea88d289" providerId="ADAL" clId="{ADEEF08A-D719-4B50-A383-4105EDA2C206}" dt="2026-03-06T15:43:07.950" v="18" actId="108"/>
-        <pc:sldMkLst>
-          <pc:docMk/>
-          <pc:sldMk cId="3265965671" sldId="2145706312"/>
-        </pc:sldMkLst>
-        <pc:spChg chg="mod">
-          <ac:chgData name="Graf Thomas, SCS-INI-NET-VNC-E2E" userId="487bc3e3-9ce7-4cdd-b7b4-8899ea88d289" providerId="ADAL" clId="{ADEEF08A-D719-4B50-A383-4105EDA2C206}" dt="2026-03-06T15:43:07.950" v="18" actId="108"/>
-          <ac:spMkLst>
-            <pc:docMk/>
-            <pc:sldMk cId="3265965671" sldId="2145706312"/>
-            <ac:spMk id="5" creationId="{FEB173FE-15D3-C438-10E8-FA80EB751145}"/>
-          </ac:spMkLst>
-        </pc:spChg>
-      </pc:sldChg>
-    </pc:docChg>
-  </pc:docChgLst>
-</pc:chgInfo>
+<file path=ppt/commentAuthors.xml><?xml version="1.0" encoding="utf-8"?>
+<p:cmAuthorLst xmlns:a="http://schemas.openxmlformats.org/drawingml/2006/main" xmlns:r="http://schemas.openxmlformats.org/officeDocument/2006/relationships" xmlns:p="http://schemas.openxmlformats.org/presentationml/2006/main">
+  <p:cmAuthor id="1" name="Wanting Du" initials="WD" lastIdx="1" clrIdx="0">
+    <p:extLst>
+      <p:ext uri="{19B8F6BF-5375-455C-9EA6-DF929625EA0E}">
+        <p15:presenceInfo xmlns:p15="http://schemas.microsoft.com/office/powerpoint/2012/main" userId="6645cbcc430c37f5" providerId="Windows Live"/>
+      </p:ext>
+    </p:extLst>
+  </p:cmAuthor>
+</p:cmAuthorLst>
+</file>
+
+<file path=ppt/comments/comment1.xml><?xml version="1.0" encoding="utf-8"?>
+<p:cmLst xmlns:a="http://schemas.openxmlformats.org/drawingml/2006/main" xmlns:r="http://schemas.openxmlformats.org/officeDocument/2006/relationships" xmlns:p="http://schemas.openxmlformats.org/presentationml/2006/main">
+  <p:cm authorId="1" dt="2026-03-03T16:39:41.366" idx="1">
+    <p:pos x="10" y="10"/>
+    <p:text>version 0.1</p:text>
+    <p:extLst>
+      <p:ext uri="{C676402C-5697-4E1C-873F-D02D1690AC5C}">
+        <p15:threadingInfo xmlns:p15="http://schemas.microsoft.com/office/powerpoint/2012/main" timeZoneBias="-60"/>
+      </p:ext>
+    </p:extLst>
+  </p:cm>
+</p:cmLst>
 </file>
 
 <file path=ppt/handoutMasters/handoutMaster1.xml><?xml version="1.0" encoding="utf-8"?>
@@ -326,7 +263,7 @@
           <a:p>
             <a:fld id="{6C04DF18-294A-1942-9DCF-44575627E94A}" type="datetimeFigureOut">
               <a:rPr lang="en-CH" smtClean="0"/>
-              <a:t>03/06/2026</a:t>
+              <a:t>06.03.2026</a:t>
             </a:fld>
             <a:endParaRPr lang="en-CH"/>
           </a:p>
@@ -503,7 +440,7 @@
           <a:p>
             <a:fld id="{773D56C8-71B6-624F-AE43-15F6568A2909}" type="datetimeFigureOut">
               <a:rPr lang="en-CH" smtClean="0"/>
-              <a:t>03/06/2026</a:t>
+              <a:t>06.03.2026</a:t>
             </a:fld>
             <a:endParaRPr lang="en-CH"/>
           </a:p>
@@ -815,6 +752,98 @@
           <a:bodyPr/>
           <a:lstStyle/>
           <a:p>
+            <a:r>
+              <a:rPr lang="en-CH" dirty="0"/>
+              <a:t>Out-scoping: </a:t>
+            </a:r>
+            <a:r>
+              <a:rPr lang="en-US" sz="1200" dirty="0"/>
+              <a:t>Rüdiger Geib</a:t>
+            </a:r>
+            <a:endParaRPr lang="en-CH" dirty="0"/>
+          </a:p>
+        </p:txBody>
+      </p:sp>
+      <p:sp>
+        <p:nvSpPr>
+          <p:cNvPr id="4" name="Slide Number Placeholder 3"/>
+          <p:cNvSpPr>
+            <a:spLocks noGrp="1"/>
+          </p:cNvSpPr>
+          <p:nvPr>
+            <p:ph type="sldNum" sz="quarter" idx="5"/>
+          </p:nvPr>
+        </p:nvSpPr>
+        <p:spPr/>
+        <p:txBody>
+          <a:bodyPr/>
+          <a:lstStyle/>
+          <a:p>
+            <a:fld id="{4C0DE7E3-6817-D34F-9F2D-16E920BB51A9}" type="slidenum">
+              <a:rPr lang="en-CH" smtClean="0"/>
+              <a:t>4</a:t>
+            </a:fld>
+            <a:endParaRPr lang="en-CH"/>
+          </a:p>
+        </p:txBody>
+      </p:sp>
+    </p:spTree>
+    <p:extLst>
+      <p:ext uri="{BB962C8B-B14F-4D97-AF65-F5344CB8AC3E}">
+        <p14:creationId xmlns:p14="http://schemas.microsoft.com/office/powerpoint/2010/main" val="4110580975"/>
+      </p:ext>
+    </p:extLst>
+  </p:cSld>
+  <p:clrMapOvr>
+    <a:masterClrMapping/>
+  </p:clrMapOvr>
+</p:notes>
+</file>
+
+<file path=ppt/notesSlides/notesSlide2.xml><?xml version="1.0" encoding="utf-8"?>
+<p:notes xmlns:a="http://schemas.openxmlformats.org/drawingml/2006/main" xmlns:r="http://schemas.openxmlformats.org/officeDocument/2006/relationships" xmlns:p="http://schemas.openxmlformats.org/presentationml/2006/main">
+  <p:cSld>
+    <p:spTree>
+      <p:nvGrpSpPr>
+        <p:cNvPr id="1" name=""/>
+        <p:cNvGrpSpPr/>
+        <p:nvPr/>
+      </p:nvGrpSpPr>
+      <p:grpSpPr>
+        <a:xfrm>
+          <a:off x="0" y="0"/>
+          <a:ext cx="0" cy="0"/>
+          <a:chOff x="0" y="0"/>
+          <a:chExt cx="0" cy="0"/>
+        </a:xfrm>
+      </p:grpSpPr>
+      <p:sp>
+        <p:nvSpPr>
+          <p:cNvPr id="2" name="Slide Image Placeholder 1"/>
+          <p:cNvSpPr>
+            <a:spLocks noGrp="1" noRot="1" noChangeAspect="1"/>
+          </p:cNvSpPr>
+          <p:nvPr>
+            <p:ph type="sldImg"/>
+          </p:nvPr>
+        </p:nvSpPr>
+        <p:spPr/>
+      </p:sp>
+      <p:sp>
+        <p:nvSpPr>
+          <p:cNvPr id="3" name="Notes Placeholder 2"/>
+          <p:cNvSpPr>
+            <a:spLocks noGrp="1"/>
+          </p:cNvSpPr>
+          <p:nvPr>
+            <p:ph type="body" idx="1"/>
+          </p:nvPr>
+        </p:nvSpPr>
+        <p:spPr/>
+        <p:txBody>
+          <a:bodyPr/>
+          <a:lstStyle/>
+          <a:p>
             <a:pPr marL="0" marR="0" lvl="0" indent="0" algn="l" defTabSz="914400" rtl="0" eaLnBrk="1" fontAlgn="auto" latinLnBrk="0" hangingPunct="1">
               <a:lnSpc>
                 <a:spcPct val="100000"/>
@@ -927,7 +956,7 @@
 </p:notes>
 </file>
 
-<file path=ppt/notesSlides/notesSlide2.xml><?xml version="1.0" encoding="utf-8"?>
+<file path=ppt/notesSlides/notesSlide3.xml><?xml version="1.0" encoding="utf-8"?>
 <p:notes xmlns:a="http://schemas.openxmlformats.org/drawingml/2006/main" xmlns:r="http://schemas.openxmlformats.org/officeDocument/2006/relationships" xmlns:p="http://schemas.openxmlformats.org/presentationml/2006/main">
   <p:cSld>
     <p:spTree>
@@ -1107,7 +1136,7 @@
 </p:notes>
 </file>
 
-<file path=ppt/notesSlides/notesSlide3.xml><?xml version="1.0" encoding="utf-8"?>
+<file path=ppt/notesSlides/notesSlide4.xml><?xml version="1.0" encoding="utf-8"?>
 <p:notes xmlns:a="http://schemas.openxmlformats.org/drawingml/2006/main" xmlns:r="http://schemas.openxmlformats.org/officeDocument/2006/relationships" xmlns:p="http://schemas.openxmlformats.org/presentationml/2006/main">
   <p:cSld>
     <p:spTree>
@@ -1191,7 +1220,7 @@
 </p:notes>
 </file>
 
-<file path=ppt/notesSlides/notesSlide4.xml><?xml version="1.0" encoding="utf-8"?>
+<file path=ppt/notesSlides/notesSlide5.xml><?xml version="1.0" encoding="utf-8"?>
 <p:notes xmlns:a="http://schemas.openxmlformats.org/drawingml/2006/main" xmlns:r="http://schemas.openxmlformats.org/officeDocument/2006/relationships" xmlns:p="http://schemas.openxmlformats.org/presentationml/2006/main">
   <p:cSld>
     <p:spTree>
@@ -1299,7 +1328,7 @@
 </p:notes>
 </file>
 
-<file path=ppt/notesSlides/notesSlide5.xml><?xml version="1.0" encoding="utf-8"?>
+<file path=ppt/notesSlides/notesSlide6.xml><?xml version="1.0" encoding="utf-8"?>
 <p:notes xmlns:a="http://schemas.openxmlformats.org/drawingml/2006/main" xmlns:r="http://schemas.openxmlformats.org/officeDocument/2006/relationships" xmlns:p="http://schemas.openxmlformats.org/presentationml/2006/main">
   <p:cSld>
     <p:spTree>
@@ -1398,6 +1427,90 @@
     <p:extLst>
       <p:ext uri="{BB962C8B-B14F-4D97-AF65-F5344CB8AC3E}">
         <p14:creationId xmlns:p14="http://schemas.microsoft.com/office/powerpoint/2010/main" val="143228700"/>
+      </p:ext>
+    </p:extLst>
+  </p:cSld>
+  <p:clrMapOvr>
+    <a:masterClrMapping/>
+  </p:clrMapOvr>
+</p:notes>
+</file>
+
+<file path=ppt/notesSlides/notesSlide7.xml><?xml version="1.0" encoding="utf-8"?>
+<p:notes xmlns:a="http://schemas.openxmlformats.org/drawingml/2006/main" xmlns:r="http://schemas.openxmlformats.org/officeDocument/2006/relationships" xmlns:p="http://schemas.openxmlformats.org/presentationml/2006/main">
+  <p:cSld>
+    <p:spTree>
+      <p:nvGrpSpPr>
+        <p:cNvPr id="1" name=""/>
+        <p:cNvGrpSpPr/>
+        <p:nvPr/>
+      </p:nvGrpSpPr>
+      <p:grpSpPr>
+        <a:xfrm>
+          <a:off x="0" y="0"/>
+          <a:ext cx="0" cy="0"/>
+          <a:chOff x="0" y="0"/>
+          <a:chExt cx="0" cy="0"/>
+        </a:xfrm>
+      </p:grpSpPr>
+      <p:sp>
+        <p:nvSpPr>
+          <p:cNvPr id="2" name="Slide Image Placeholder 1"/>
+          <p:cNvSpPr>
+            <a:spLocks noGrp="1" noRot="1" noChangeAspect="1"/>
+          </p:cNvSpPr>
+          <p:nvPr>
+            <p:ph type="sldImg"/>
+          </p:nvPr>
+        </p:nvSpPr>
+        <p:spPr/>
+      </p:sp>
+      <p:sp>
+        <p:nvSpPr>
+          <p:cNvPr id="3" name="Notes Placeholder 2"/>
+          <p:cNvSpPr>
+            <a:spLocks noGrp="1"/>
+          </p:cNvSpPr>
+          <p:nvPr>
+            <p:ph type="body" idx="1"/>
+          </p:nvPr>
+        </p:nvSpPr>
+        <p:spPr/>
+        <p:txBody>
+          <a:bodyPr/>
+          <a:lstStyle/>
+          <a:p>
+            <a:endParaRPr lang="en-CH" dirty="0"/>
+          </a:p>
+        </p:txBody>
+      </p:sp>
+      <p:sp>
+        <p:nvSpPr>
+          <p:cNvPr id="4" name="Slide Number Placeholder 3"/>
+          <p:cNvSpPr>
+            <a:spLocks noGrp="1"/>
+          </p:cNvSpPr>
+          <p:nvPr>
+            <p:ph type="sldNum" sz="quarter" idx="5"/>
+          </p:nvPr>
+        </p:nvSpPr>
+        <p:spPr/>
+        <p:txBody>
+          <a:bodyPr/>
+          <a:lstStyle/>
+          <a:p>
+            <a:fld id="{4C0DE7E3-6817-D34F-9F2D-16E920BB51A9}" type="slidenum">
+              <a:rPr lang="en-CH" smtClean="0"/>
+              <a:t>12</a:t>
+            </a:fld>
+            <a:endParaRPr lang="en-CH"/>
+          </a:p>
+        </p:txBody>
+      </p:sp>
+    </p:spTree>
+    <p:extLst>
+      <p:ext uri="{BB962C8B-B14F-4D97-AF65-F5344CB8AC3E}">
+        <p14:creationId xmlns:p14="http://schemas.microsoft.com/office/powerpoint/2010/main" val="2412726011"/>
       </p:ext>
     </p:extLst>
   </p:cSld>
@@ -1586,7 +1699,7 @@
           <a:p>
             <a:fld id="{7E003D89-8BCB-CD45-BFFB-53322C8FC40E}" type="datetime1">
               <a:rPr lang="de-CH" smtClean="0"/>
-              <a:t>06.03.2026</a:t>
+              <a:t>06.03.26</a:t>
             </a:fld>
             <a:endParaRPr lang="en-US"/>
           </a:p>
@@ -1735,7 +1848,7 @@
           <a:p>
             <a:fld id="{79121205-D078-FD46-AF85-0EF064AD968E}" type="datetime1">
               <a:rPr lang="de-CH" smtClean="0"/>
-              <a:t>06.03.2026</a:t>
+              <a:t>06.03.26</a:t>
             </a:fld>
             <a:endParaRPr lang="en-US"/>
           </a:p>
@@ -1894,7 +2007,7 @@
           <a:p>
             <a:fld id="{CD8CCE81-C62E-2040-8EF1-B2DD76AF35C8}" type="datetime1">
               <a:rPr lang="de-CH" smtClean="0"/>
-              <a:t>06.03.2026</a:t>
+              <a:t>06.03.26</a:t>
             </a:fld>
             <a:endParaRPr lang="en-US" dirty="0"/>
           </a:p>
@@ -2092,7 +2205,7 @@
               <a:rPr lang="en-US"/>
               <a:t>Introduction to Telemetry </a:t>
             </a:r>
-            <a:endParaRPr lang="en-GB" dirty="0"/>
+            <a:endParaRPr lang="en-GB"/>
           </a:p>
         </p:txBody>
       </p:sp>
@@ -2155,7 +2268,7 @@
           <a:p>
             <a:fld id="{79121205-D078-FD46-AF85-0EF064AD968E}" type="datetime1">
               <a:rPr lang="de-CH" smtClean="0"/>
-              <a:t>06.03.2026</a:t>
+              <a:t>06.03.26</a:t>
             </a:fld>
             <a:endParaRPr lang="en-US"/>
           </a:p>
@@ -2320,7 +2433,7 @@
           <a:p>
             <a:fld id="{B79D91F7-C961-8C44-9299-BF84FF39514E}" type="datetime1">
               <a:rPr lang="de-CH" smtClean="0"/>
-              <a:t>06.03.2026</a:t>
+              <a:t>06.03.26</a:t>
             </a:fld>
             <a:endParaRPr lang="en-US"/>
           </a:p>
@@ -2546,7 +2659,7 @@
           <a:p>
             <a:fld id="{FEC2240F-8AA3-2746-9A51-9D1A136F1E49}" type="datetime1">
               <a:rPr lang="de-CH" smtClean="0"/>
-              <a:t>06.03.2026</a:t>
+              <a:t>06.03.26</a:t>
             </a:fld>
             <a:endParaRPr lang="en-US"/>
           </a:p>
@@ -2812,7 +2925,7 @@
           <a:p>
             <a:fld id="{03314D2E-D8E2-384B-82FD-655D508953A3}" type="datetime1">
               <a:rPr lang="de-CH" smtClean="0"/>
-              <a:t>06.03.2026</a:t>
+              <a:t>06.03.26</a:t>
             </a:fld>
             <a:endParaRPr lang="en-US"/>
           </a:p>
@@ -3078,7 +3191,7 @@
           <a:p>
             <a:fld id="{EDA34BA8-55CE-D34A-9C2D-BEEE7446B5FC}" type="datetime1">
               <a:rPr lang="de-CH" smtClean="0"/>
-              <a:t>06.03.2026</a:t>
+              <a:t>06.03.26</a:t>
             </a:fld>
             <a:endParaRPr lang="en-US"/>
           </a:p>
@@ -3176,7 +3289,7 @@
           <a:p>
             <a:fld id="{C469DC1D-08EC-344C-AFC6-70566B114C19}" type="datetime1">
               <a:rPr lang="de-CH" smtClean="0"/>
-              <a:t>06.03.2026</a:t>
+              <a:t>06.03.26</a:t>
             </a:fld>
             <a:endParaRPr lang="en-US"/>
           </a:p>
@@ -3252,7 +3365,7 @@
           <a:p>
             <a:fld id="{B90EF599-0014-1B46-9369-317248A83AAA}" type="datetime1">
               <a:rPr lang="de-CH" smtClean="0"/>
-              <a:t>06.03.2026</a:t>
+              <a:t>06.03.26</a:t>
             </a:fld>
             <a:endParaRPr lang="en-US"/>
           </a:p>
@@ -3508,7 +3621,7 @@
           <a:p>
             <a:fld id="{B21C5E05-3C90-7247-87A0-D89349E8E13C}" type="datetime1">
               <a:rPr lang="de-CH" smtClean="0"/>
-              <a:t>06.03.2026</a:t>
+              <a:t>06.03.26</a:t>
             </a:fld>
             <a:endParaRPr lang="en-US"/>
           </a:p>
@@ -3741,7 +3854,7 @@
           <a:p>
             <a:fld id="{AD65A632-B168-4E45-8147-A4CCCC7F8728}" type="datetime1">
               <a:rPr lang="de-CH" smtClean="0"/>
-              <a:t>06.03.2026</a:t>
+              <a:t>06.03.26</a:t>
             </a:fld>
             <a:endParaRPr lang="en-US"/>
           </a:p>
@@ -3933,7 +4046,7 @@
           <a:p>
             <a:fld id="{7291580A-F933-684E-A19D-31DC6358EE9E}" type="datetime1">
               <a:rPr lang="de-CH" smtClean="0"/>
-              <a:t>06.03.2026</a:t>
+              <a:t>06.03.26</a:t>
             </a:fld>
             <a:endParaRPr lang="en-US"/>
           </a:p>
@@ -4321,11 +4434,11 @@
           </a:lstStyle>
           <a:p>
             <a:r>
-              <a:rPr lang="en-US" sz="2550" b="1"/>
+              <a:rPr lang="en-US" sz="2550" b="1" dirty="0"/>
               <a:t>An Architecture for a </a:t>
             </a:r>
             <a:r>
-              <a:rPr lang="en-US" sz="2550" b="1">
+              <a:rPr lang="en-US" sz="2550" b="1" dirty="0">
                 <a:solidFill>
                   <a:srgbClr val="FF0000"/>
                 </a:solidFill>
@@ -4333,7 +4446,7 @@
               <a:t>Network Anomaly Detection </a:t>
             </a:r>
             <a:r>
-              <a:rPr lang="en-US" sz="2550" b="1"/>
+              <a:rPr lang="en-US" sz="2550" b="1" dirty="0"/>
               <a:t>Framework </a:t>
             </a:r>
             <a:br>
@@ -4361,7 +4474,7 @@
           </a:p>
           <a:p>
             <a:r>
-              <a:rPr lang="en-US" sz="2100">
+              <a:rPr lang="en-US" sz="2100" dirty="0">
                 <a:solidFill>
                   <a:schemeClr val="bg2">
                     <a:lumMod val="75000"/>
@@ -4370,17 +4483,10 @@
               </a:rPr>
               <a:t>Motivation and architecture of a Network Anomaly Detection Framework</a:t>
             </a:r>
-            <a:endParaRPr lang="en-US" sz="2100" dirty="0">
-              <a:solidFill>
-                <a:schemeClr val="bg2">
-                  <a:lumMod val="75000"/>
-                </a:schemeClr>
-              </a:solidFill>
-            </a:endParaRPr>
-          </a:p>
-          <a:p>
-            <a:r>
-              <a:rPr lang="en-US" sz="2100">
+          </a:p>
+          <a:p>
+            <a:r>
+              <a:rPr lang="en-US" sz="2100" dirty="0">
                 <a:solidFill>
                   <a:schemeClr val="bg2">
                     <a:lumMod val="75000"/>
@@ -4389,17 +4495,10 @@
               </a:rPr>
               <a:t>    and the relationships to other documents describing</a:t>
             </a:r>
-            <a:endParaRPr lang="en-US" sz="2100" dirty="0">
-              <a:solidFill>
-                <a:schemeClr val="bg2">
-                  <a:lumMod val="75000"/>
-                </a:schemeClr>
-              </a:solidFill>
-            </a:endParaRPr>
-          </a:p>
-          <a:p>
-            <a:r>
-              <a:rPr lang="en-US" sz="2100">
+          </a:p>
+          <a:p>
+            <a:r>
+              <a:rPr lang="en-US" sz="2100" dirty="0">
                 <a:solidFill>
                   <a:schemeClr val="bg2">
                     <a:lumMod val="75000"/>
@@ -4408,13 +4507,6 @@
               </a:rPr>
               <a:t>        network symptom semantics and network incident lifecycle</a:t>
             </a:r>
-            <a:endParaRPr lang="en-US" sz="2100" dirty="0">
-              <a:solidFill>
-                <a:schemeClr val="bg2">
-                  <a:lumMod val="75000"/>
-                </a:schemeClr>
-              </a:solidFill>
-            </a:endParaRPr>
           </a:p>
         </p:txBody>
       </p:sp>
@@ -4703,9 +4795,9 @@
           <a:p>
             <a:fld id="{72B55B63-FDB8-D940-A236-AF8A5F46C494}" type="datetime1">
               <a:rPr lang="de-CH" smtClean="0"/>
-              <a:t>06.03.2026</a:t>
+              <a:t>06.03.26</a:t>
             </a:fld>
-            <a:endParaRPr lang="en-US"/>
+            <a:endParaRPr lang="en-US" dirty="0"/>
           </a:p>
         </p:txBody>
       </p:sp>
@@ -4735,6 +4827,38 @@
               <a:t>1</a:t>
             </a:fld>
             <a:endParaRPr lang="en-US"/>
+          </a:p>
+        </p:txBody>
+      </p:sp>
+      <p:sp>
+        <p:nvSpPr>
+          <p:cNvPr id="2" name="TextBox 1">
+            <a:extLst>
+              <a:ext uri="{FF2B5EF4-FFF2-40B4-BE49-F238E27FC236}">
+                <a16:creationId xmlns:a16="http://schemas.microsoft.com/office/drawing/2014/main" id="{B96F14DD-DA49-5D8A-34C3-1676818C68D0}"/>
+              </a:ext>
+            </a:extLst>
+          </p:cNvPr>
+          <p:cNvSpPr txBox="1"/>
+          <p:nvPr/>
+        </p:nvSpPr>
+        <p:spPr>
+          <a:xfrm>
+            <a:off x="3911600" y="5346700"/>
+            <a:ext cx="184731" cy="369332"/>
+          </a:xfrm>
+          <a:prstGeom prst="rect">
+            <a:avLst/>
+          </a:prstGeom>
+          <a:noFill/>
+        </p:spPr>
+        <p:txBody>
+          <a:bodyPr wrap="none" rtlCol="0">
+            <a:spAutoFit/>
+          </a:bodyPr>
+          <a:lstStyle/>
+          <a:p>
+            <a:endParaRPr lang="en-CH"/>
           </a:p>
         </p:txBody>
       </p:sp>
@@ -4748,6 +4872,14 @@
   <p:clrMapOvr>
     <a:masterClrMapping/>
   </p:clrMapOvr>
+  <mc:AlternateContent xmlns:mc="http://schemas.openxmlformats.org/markup-compatibility/2006">
+    <mc:Choice xmlns:p14="http://schemas.microsoft.com/office/powerpoint/2010/main" Requires="p14">
+      <p:transition spd="slow" p14:dur="2000" advTm="8774"/>
+    </mc:Choice>
+    <mc:Fallback>
+      <p:transition spd="slow" advTm="8774"/>
+    </mc:Fallback>
+  </mc:AlternateContent>
 </p:sld>
 </file>
 
@@ -4947,7 +5079,7 @@
           <a:p>
             <a:fld id="{DACD52A1-C0F7-0F48-BE0F-BBA5E31D6A37}" type="datetime1">
               <a:rPr lang="de-CH" smtClean="0"/>
-              <a:t>06.03.2026</a:t>
+              <a:t>06.03.26</a:t>
             </a:fld>
             <a:endParaRPr lang="en-US"/>
           </a:p>
@@ -5117,7 +5249,7 @@
                   </a:schemeClr>
                 </a:solidFill>
               </a:rPr>
-              <a:t>Key draft updates since -03</a:t>
+              <a:t>Key draft updates since v-03</a:t>
             </a:r>
           </a:p>
         </p:txBody>
@@ -5592,7 +5724,7 @@
           <a:p>
             <a:fld id="{6CCDDB14-30A2-2E47-B57D-285D0E17FE10}" type="datetime1">
               <a:rPr lang="de-CH" smtClean="0"/>
-              <a:t>06.03.2026</a:t>
+              <a:t>06.03.26</a:t>
             </a:fld>
             <a:endParaRPr lang="en-US"/>
           </a:p>
@@ -5801,10 +5933,9 @@
               </a:spcAft>
             </a:pPr>
             <a:r>
-              <a:rPr lang="en-US" sz="1400" b="1"/>
+              <a:rPr lang="en-US" sz="1400" b="1" dirty="0"/>
               <a:t>Terminology update</a:t>
             </a:r>
-            <a:endParaRPr lang="en-US" sz="1400" b="1" dirty="0"/>
           </a:p>
           <a:p>
             <a:pPr lvl="1">
@@ -5816,20 +5947,8 @@
               </a:spcAft>
             </a:pPr>
             <a:r>
-              <a:rPr lang="en-GB" sz="1400"/>
-              <a:t>Streamlined “</a:t>
-            </a:r>
-            <a:r>
               <a:rPr lang="en-GB" sz="1400" dirty="0"/>
-              <a:t>state/</a:t>
-            </a:r>
-            <a:r>
-              <a:rPr lang="en-GB" sz="1400"/>
-              <a:t>phase” -&gt; “</a:t>
-            </a:r>
-            <a:r>
-              <a:rPr lang="en-GB" sz="1400" dirty="0"/>
-              <a:t>stage”</a:t>
+              <a:t>Renamed “state/phase” to “stage” to avoid confusion with protocol “states”</a:t>
             </a:r>
             <a:r>
               <a:rPr lang="en-US" sz="1400" dirty="0"/>
@@ -5846,10 +5965,9 @@
               </a:spcAft>
             </a:pPr>
             <a:r>
-              <a:rPr lang="en-US" sz="1400" b="1"/>
+              <a:rPr lang="en-US" sz="1400" b="1" dirty="0"/>
               <a:t>Schema change</a:t>
             </a:r>
-            <a:endParaRPr lang="en-US" sz="1400" b="1" dirty="0"/>
           </a:p>
           <a:p>
             <a:pPr lvl="1">
@@ -5863,12 +5981,8 @@
               <a:buChar char="-"/>
             </a:pPr>
             <a:r>
-              <a:rPr lang="en-GB" sz="1400"/>
-              <a:t>Changed “state” -&gt; “</a:t>
-            </a:r>
-            <a:r>
               <a:rPr lang="en-GB" sz="1400" dirty="0"/>
-              <a:t>stage”</a:t>
+              <a:t>Changed “state” -&gt; “stage”</a:t>
             </a:r>
           </a:p>
           <a:p>
@@ -5883,12 +5997,8 @@
               <a:buChar char="-"/>
             </a:pPr>
             <a:r>
-              <a:rPr lang="en-GB" sz="1400"/>
-              <a:t>Fixed RFC 8407 related Yang warnings (remove mandatory false</a:t>
-            </a:r>
-            <a:r>
               <a:rPr lang="en-GB" sz="1400" dirty="0"/>
-              <a:t>)</a:t>
+              <a:t>Fixed RFC 8407 related Yang warnings (remove mandatory false)</a:t>
             </a:r>
           </a:p>
           <a:p>
@@ -5903,12 +6013,8 @@
               <a:buChar char="-"/>
             </a:pPr>
             <a:r>
-              <a:rPr lang="en-GB" sz="1400"/>
-              <a:t>Include operational data in anomaly and introduce “</a:t>
-            </a:r>
-            <a:r>
               <a:rPr lang="en-GB" sz="1400" dirty="0"/>
-              <a:t>message-broker-grouping”</a:t>
+              <a:t>Include operational data in anomaly and introduce “message-broker-grouping”</a:t>
             </a:r>
           </a:p>
           <a:p>
@@ -5921,10 +6027,9 @@
               </a:spcAft>
             </a:pPr>
             <a:r>
-              <a:rPr lang="en-GB" sz="1400" b="1"/>
+              <a:rPr lang="en-GB" sz="1400" b="1" dirty="0"/>
               <a:t>Refinement </a:t>
             </a:r>
-            <a:endParaRPr lang="en-GB" sz="1400" b="1" dirty="0"/>
           </a:p>
           <a:p>
             <a:pPr lvl="1">
@@ -5936,10 +6041,9 @@
               </a:spcAft>
             </a:pPr>
             <a:r>
-              <a:rPr lang="en-GB" sz="1400"/>
+              <a:rPr lang="en-GB" sz="1400" dirty="0"/>
               <a:t>Refined definition of confidence score and concern score</a:t>
             </a:r>
-            <a:endParaRPr lang="en-GB" sz="1400" dirty="0"/>
           </a:p>
           <a:p>
             <a:pPr lvl="1">
@@ -5951,10 +6055,9 @@
               </a:spcAft>
             </a:pPr>
             <a:r>
-              <a:rPr lang="en-GB" sz="1400"/>
+              <a:rPr lang="en-GB" sz="1400" dirty="0"/>
               <a:t>Optimized Figure 2</a:t>
             </a:r>
-            <a:endParaRPr lang="en-GB" sz="1400" dirty="0"/>
           </a:p>
           <a:p>
             <a:pPr lvl="1">
@@ -5966,10 +6069,9 @@
               </a:spcAft>
             </a:pPr>
             <a:r>
-              <a:rPr lang="en-GB" sz="1400"/>
+              <a:rPr lang="en-GB" sz="1400" dirty="0"/>
               <a:t>Consolidated the usage of score across different drafts </a:t>
             </a:r>
-            <a:endParaRPr lang="en-GB" sz="1400" dirty="0"/>
           </a:p>
         </p:txBody>
       </p:sp>
@@ -6269,7 +6371,7 @@
             </a:r>
             <a:r>
               <a:rPr lang="en-US" sz="1600" dirty="0">
-                <a:hlinkClick r:id="rId2"/>
+                <a:hlinkClick r:id="rId3"/>
               </a:rPr>
               <a:t>draft-ietf-nmop-network-anomaly-semantics-05</a:t>
             </a:r>
@@ -6279,7 +6381,7 @@
             </a:r>
             <a:r>
               <a:rPr lang="en-US" sz="1600" dirty="0">
-                <a:hlinkClick r:id="rId3"/>
+                <a:hlinkClick r:id="rId4"/>
               </a:rPr>
               <a:t>draft-ietf-nmop-network-anomaly-lifecycle-05</a:t>
             </a:r>
@@ -6287,17 +6389,6 @@
               <a:rPr lang="en-US" sz="1600" dirty="0"/>
               <a:t>.</a:t>
             </a:r>
-          </a:p>
-          <a:p>
-            <a:pPr>
-              <a:spcBef>
-                <a:spcPts val="300"/>
-              </a:spcBef>
-              <a:spcAft>
-                <a:spcPts val="300"/>
-              </a:spcAft>
-            </a:pPr>
-            <a:endParaRPr lang="en-US" sz="1600" dirty="0"/>
           </a:p>
           <a:p>
             <a:pPr marL="285750" indent="-285750">
@@ -6312,18 +6403,7 @@
             </a:pPr>
             <a:r>
               <a:rPr lang="en-US" sz="1600" dirty="0"/>
-              <a:t>Implement semantic metadata in Cosmos Bright Lights to replace placeholders “null” for newly introduced fields.</a:t>
-            </a:r>
-          </a:p>
-          <a:p>
-            <a:pPr>
-              <a:spcBef>
-                <a:spcPts val="2400"/>
-              </a:spcBef>
-            </a:pPr>
-            <a:r>
-              <a:rPr lang="en-IE" sz="1400" b="1" dirty="0"/>
-              <a:t>Open Issues</a:t>
+              <a:t>Implement semantic metadata in Cosmos Bright Lights to replace placeholder values (null) for newly introduced fields, including site‑ids, interface names, and VRF names.</a:t>
             </a:r>
           </a:p>
           <a:p>
@@ -6338,9 +6418,56 @@
               <a:buChar char="•"/>
             </a:pPr>
             <a:r>
+              <a:rPr lang="en-US" sz="1600" dirty="0"/>
+              <a:t>Extend the postmortem system requirements, accompanied by an implementation proof of concept</a:t>
+            </a:r>
+          </a:p>
+          <a:p>
+            <a:pPr marL="285750" indent="-285750">
+              <a:spcBef>
+                <a:spcPts val="300"/>
+              </a:spcBef>
+              <a:spcAft>
+                <a:spcPts val="300"/>
+              </a:spcAft>
+              <a:buFont typeface="Arial" panose="020B0604020202020204" pitchFamily="34" charset="0"/>
+              <a:buChar char="•"/>
+            </a:pPr>
+            <a:endParaRPr lang="en-US" sz="1600" dirty="0"/>
+          </a:p>
+          <a:p>
+            <a:pPr>
+              <a:spcBef>
+                <a:spcPts val="300"/>
+              </a:spcBef>
+              <a:spcAft>
+                <a:spcPts val="300"/>
+              </a:spcAft>
+            </a:pPr>
+            <a:r>
+              <a:rPr lang="en-IE" sz="1400" b="1" dirty="0"/>
+              <a:t>Remaining Issue</a:t>
+            </a:r>
+          </a:p>
+          <a:p>
+            <a:pPr marL="285750" indent="-285750">
+              <a:spcBef>
+                <a:spcPts val="300"/>
+              </a:spcBef>
+              <a:spcAft>
+                <a:spcPts val="300"/>
+              </a:spcAft>
+              <a:buFont typeface="Arial" panose="020B0604020202020204" pitchFamily="34" charset="0"/>
+              <a:buChar char="•"/>
+            </a:pPr>
+            <a:r>
               <a:rPr lang="en-IE" sz="1600" dirty="0"/>
-              <a:t>None</a:t>
-            </a:r>
+              <a:t>No known remaining issues at this time. Further feedback from the working group is expected as the drafts progress.</a:t>
+            </a:r>
+            <a:br>
+              <a:rPr lang="en-IE" sz="1600" dirty="0"/>
+            </a:br>
+            <a:endParaRPr lang="en-IE" sz="1600" dirty="0"/>
           </a:p>
         </p:txBody>
       </p:sp>
@@ -6739,7 +6866,7 @@
             </a:r>
             <a:r>
               <a:rPr lang="en-US" sz="1600" dirty="0"/>
-              <a:t> describes the motivation and architecture and the relationship to other two documents.</a:t>
+              <a:t> describes the motivation, architecture and the relationship to other two documents.</a:t>
             </a:r>
             <a:endParaRPr lang="en-GB" sz="1600" dirty="0"/>
           </a:p>
@@ -7423,6 +7550,14 @@
   <p:clrMapOvr>
     <a:masterClrMapping/>
   </p:clrMapOvr>
+  <mc:AlternateContent xmlns:mc="http://schemas.openxmlformats.org/markup-compatibility/2006">
+    <mc:Choice xmlns:p14="http://schemas.microsoft.com/office/powerpoint/2010/main" Requires="p14">
+      <p:transition spd="slow" p14:dur="2000" advTm="2903"/>
+    </mc:Choice>
+    <mc:Fallback>
+      <p:transition spd="slow" advTm="2903"/>
+    </mc:Fallback>
+  </mc:AlternateContent>
 </p:sld>
 </file>
 
@@ -7683,7 +7818,7 @@
           <a:p>
             <a:fld id="{AF901AE6-770F-8841-B36C-9BB82D836878}" type="datetime1">
               <a:rPr lang="de-CH" smtClean="0"/>
-              <a:t>06.03.2026</a:t>
+              <a:t>06.03.26</a:t>
             </a:fld>
             <a:endParaRPr lang="en-US"/>
           </a:p>
@@ -7728,6 +7863,14 @@
   <p:clrMapOvr>
     <a:masterClrMapping/>
   </p:clrMapOvr>
+  <mc:AlternateContent xmlns:mc="http://schemas.openxmlformats.org/markup-compatibility/2006">
+    <mc:Choice xmlns:p14="http://schemas.microsoft.com/office/powerpoint/2010/main" Requires="p14">
+      <p:transition spd="slow" p14:dur="2000" advTm="2658"/>
+    </mc:Choice>
+    <mc:Fallback>
+      <p:transition spd="slow" advTm="2658"/>
+    </mc:Fallback>
+  </mc:AlternateContent>
 </p:sld>
 </file>
 
@@ -7756,6 +7899,204 @@
       </p:grpSpPr>
       <p:sp>
         <p:nvSpPr>
+          <p:cNvPr id="3" name="Content Placeholder 2">
+            <a:extLst>
+              <a:ext uri="{FF2B5EF4-FFF2-40B4-BE49-F238E27FC236}">
+                <a16:creationId xmlns:a16="http://schemas.microsoft.com/office/drawing/2014/main" id="{AA209B5F-12F6-9A75-A5C8-FB699F15D6EB}"/>
+              </a:ext>
+            </a:extLst>
+          </p:cNvPr>
+          <p:cNvSpPr>
+            <a:spLocks noGrp="1"/>
+          </p:cNvSpPr>
+          <p:nvPr>
+            <p:ph idx="1"/>
+          </p:nvPr>
+        </p:nvSpPr>
+        <p:spPr>
+          <a:xfrm>
+            <a:off x="576000" y="1440000"/>
+            <a:ext cx="7939350" cy="4551726"/>
+          </a:xfrm>
+        </p:spPr>
+        <p:txBody>
+          <a:bodyPr>
+            <a:noAutofit/>
+          </a:bodyPr>
+          <a:lstStyle/>
+          <a:p>
+            <a:pPr>
+              <a:spcBef>
+                <a:spcPts val="225"/>
+              </a:spcBef>
+              <a:spcAft>
+                <a:spcPts val="225"/>
+              </a:spcAft>
+            </a:pPr>
+            <a:r>
+              <a:rPr lang="en-US" sz="1400" b="1" dirty="0"/>
+              <a:t>Terminology update</a:t>
+            </a:r>
+          </a:p>
+          <a:p>
+            <a:pPr lvl="1">
+              <a:spcBef>
+                <a:spcPts val="225"/>
+              </a:spcBef>
+              <a:spcAft>
+                <a:spcPts val="225"/>
+              </a:spcAft>
+            </a:pPr>
+            <a:r>
+              <a:rPr lang="en-US" sz="1400" dirty="0"/>
+              <a:t>Change from “customer profile” to “service profile” </a:t>
+            </a:r>
+            <a:r>
+              <a:rPr lang="en-GB" sz="1400" dirty="0"/>
+              <a:t>to ensure consistency across reference documentation (RFC 8969).</a:t>
+            </a:r>
+          </a:p>
+          <a:p>
+            <a:pPr lvl="1">
+              <a:spcBef>
+                <a:spcPts val="225"/>
+              </a:spcBef>
+              <a:spcAft>
+                <a:spcPts val="225"/>
+              </a:spcAft>
+            </a:pPr>
+            <a:r>
+              <a:rPr lang="en-GB" sz="1400" dirty="0"/>
+              <a:t>Added formal “Rules" definition</a:t>
+            </a:r>
+            <a:r>
+              <a:rPr lang="en-US" sz="1400" dirty="0"/>
+              <a:t> to distinguish between knowledge-based approach and ML approach.</a:t>
+            </a:r>
+          </a:p>
+          <a:p>
+            <a:pPr>
+              <a:spcBef>
+                <a:spcPts val="225"/>
+              </a:spcBef>
+              <a:spcAft>
+                <a:spcPts val="225"/>
+              </a:spcAft>
+            </a:pPr>
+            <a:r>
+              <a:rPr lang="en-US" sz="1400" b="1" dirty="0"/>
+              <a:t>Restructure</a:t>
+            </a:r>
+          </a:p>
+          <a:p>
+            <a:pPr lvl="1">
+              <a:spcBef>
+                <a:spcPts val="225"/>
+              </a:spcBef>
+              <a:spcAft>
+                <a:spcPts val="225"/>
+              </a:spcAft>
+              <a:buFontTx/>
+              <a:buChar char="-"/>
+            </a:pPr>
+            <a:r>
+              <a:rPr lang="en-GB" sz="1400" dirty="0"/>
+              <a:t>Restructured Service Disruption Section:</a:t>
+            </a:r>
+          </a:p>
+          <a:p>
+            <a:pPr lvl="2">
+              <a:spcBef>
+                <a:spcPts val="225"/>
+              </a:spcBef>
+              <a:spcAft>
+                <a:spcPts val="225"/>
+              </a:spcAft>
+              <a:buFontTx/>
+              <a:buChar char="-"/>
+            </a:pPr>
+            <a:r>
+              <a:rPr lang="en-GB" sz="1400" dirty="0"/>
+              <a:t>Added sections on Knowledge Based and detailed it with subsections including Expert Rules, Network </a:t>
+            </a:r>
+            <a:r>
+              <a:rPr lang="en-GB" sz="1400" dirty="0" err="1"/>
+              <a:t>Modeling</a:t>
+            </a:r>
+            <a:r>
+              <a:rPr lang="en-GB" sz="1400" dirty="0"/>
+              <a:t>, Data Profiling, and Detection Strategies. </a:t>
+            </a:r>
+          </a:p>
+          <a:p>
+            <a:pPr lvl="2">
+              <a:spcBef>
+                <a:spcPts val="225"/>
+              </a:spcBef>
+              <a:spcAft>
+                <a:spcPts val="225"/>
+              </a:spcAft>
+              <a:buFontTx/>
+              <a:buChar char="-"/>
+            </a:pPr>
+            <a:r>
+              <a:rPr lang="en-GB" sz="1400" dirty="0"/>
+              <a:t>ML part moved to "Conventions” along with “Knowledge Based Detection”, and referenced in "Data Profiling”</a:t>
+            </a:r>
+          </a:p>
+          <a:p>
+            <a:pPr>
+              <a:spcBef>
+                <a:spcPts val="225"/>
+              </a:spcBef>
+              <a:spcAft>
+                <a:spcPts val="225"/>
+              </a:spcAft>
+            </a:pPr>
+            <a:r>
+              <a:rPr lang="en-GB" sz="1400" b="1" dirty="0"/>
+              <a:t>Refinement</a:t>
+            </a:r>
+          </a:p>
+          <a:p>
+            <a:pPr lvl="1"/>
+            <a:r>
+              <a:rPr lang="en-GB" sz="1400" dirty="0"/>
+              <a:t>Clarified the relationship between Semantic, Rule, &amp; Knowledge-based detection.</a:t>
+            </a:r>
+          </a:p>
+          <a:p>
+            <a:pPr lvl="1"/>
+            <a:r>
+              <a:rPr lang="en-GB" sz="1400" dirty="0"/>
+              <a:t>Refined definition: collective outlier, confidence score, concern score. </a:t>
+            </a:r>
+          </a:p>
+          <a:p>
+            <a:pPr lvl="1"/>
+            <a:r>
+              <a:rPr lang="en-GB" sz="1400" dirty="0"/>
+              <a:t>Refined clarification: Alarm-raising criteria, Data Storage Considerations, Operational Data Aggregation</a:t>
+            </a:r>
+          </a:p>
+          <a:p>
+            <a:r>
+              <a:rPr lang="en-GB" sz="1400" dirty="0"/>
+              <a:t> Explicitly </a:t>
+            </a:r>
+            <a:r>
+              <a:rPr lang="en-GB" sz="1400" b="1" dirty="0"/>
+              <a:t>out-scoped</a:t>
+            </a:r>
+            <a:r>
+              <a:rPr lang="en-GB" sz="1400" dirty="0"/>
+              <a:t> Service Degradation based on WG review feedback</a:t>
+            </a:r>
+          </a:p>
+        </p:txBody>
+      </p:sp>
+      <p:sp>
+        <p:nvSpPr>
           <p:cNvPr id="2" name="Title 1">
             <a:extLst>
               <a:ext uri="{FF2B5EF4-FFF2-40B4-BE49-F238E27FC236}">
@@ -7793,197 +8134,7 @@
                   </a:schemeClr>
                 </a:solidFill>
               </a:rPr>
-              <a:t>Key draft updates since -05</a:t>
-            </a:r>
-          </a:p>
-        </p:txBody>
-      </p:sp>
-      <p:sp>
-        <p:nvSpPr>
-          <p:cNvPr id="3" name="Content Placeholder 2">
-            <a:extLst>
-              <a:ext uri="{FF2B5EF4-FFF2-40B4-BE49-F238E27FC236}">
-                <a16:creationId xmlns:a16="http://schemas.microsoft.com/office/drawing/2014/main" id="{AA209B5F-12F6-9A75-A5C8-FB699F15D6EB}"/>
-              </a:ext>
-            </a:extLst>
-          </p:cNvPr>
-          <p:cNvSpPr>
-            <a:spLocks noGrp="1"/>
-          </p:cNvSpPr>
-          <p:nvPr>
-            <p:ph idx="1"/>
-          </p:nvPr>
-        </p:nvSpPr>
-        <p:spPr>
-          <a:xfrm>
-            <a:off x="576000" y="1440000"/>
-            <a:ext cx="7939350" cy="4551726"/>
-          </a:xfrm>
-        </p:spPr>
-        <p:txBody>
-          <a:bodyPr>
-            <a:noAutofit/>
-          </a:bodyPr>
-          <a:lstStyle/>
-          <a:p>
-            <a:pPr>
-              <a:spcBef>
-                <a:spcPts val="225"/>
-              </a:spcBef>
-              <a:spcAft>
-                <a:spcPts val="225"/>
-              </a:spcAft>
-            </a:pPr>
-            <a:r>
-              <a:rPr lang="en-US" sz="1400" b="1" dirty="0"/>
-              <a:t>Terminology update</a:t>
-            </a:r>
-          </a:p>
-          <a:p>
-            <a:pPr lvl="1">
-              <a:spcBef>
-                <a:spcPts val="225"/>
-              </a:spcBef>
-              <a:spcAft>
-                <a:spcPts val="225"/>
-              </a:spcAft>
-            </a:pPr>
-            <a:r>
-              <a:rPr lang="en-US" sz="1400" dirty="0"/>
-              <a:t>Change from “customer profile” to “service profile” </a:t>
-            </a:r>
-            <a:r>
-              <a:rPr lang="en-GB" sz="1400" dirty="0"/>
-              <a:t>to ensure consistency across reference documentation.</a:t>
-            </a:r>
-          </a:p>
-          <a:p>
-            <a:pPr lvl="1">
-              <a:spcBef>
-                <a:spcPts val="225"/>
-              </a:spcBef>
-              <a:spcAft>
-                <a:spcPts val="225"/>
-              </a:spcAft>
-            </a:pPr>
-            <a:r>
-              <a:rPr lang="en-GB" sz="1400" dirty="0"/>
-              <a:t>Added formal “Rules" definition</a:t>
-            </a:r>
-            <a:r>
-              <a:rPr lang="en-US" sz="1400" dirty="0"/>
-              <a:t> to distinguish between knowledge-based approach and ML approach.</a:t>
-            </a:r>
-          </a:p>
-          <a:p>
-            <a:pPr>
-              <a:spcBef>
-                <a:spcPts val="225"/>
-              </a:spcBef>
-              <a:spcAft>
-                <a:spcPts val="225"/>
-              </a:spcAft>
-            </a:pPr>
-            <a:r>
-              <a:rPr lang="en-US" sz="1400" b="1" dirty="0"/>
-              <a:t>Restructure</a:t>
-            </a:r>
-          </a:p>
-          <a:p>
-            <a:pPr lvl="1">
-              <a:spcBef>
-                <a:spcPts val="225"/>
-              </a:spcBef>
-              <a:spcAft>
-                <a:spcPts val="225"/>
-              </a:spcAft>
-              <a:buFontTx/>
-              <a:buChar char="-"/>
-            </a:pPr>
-            <a:r>
-              <a:rPr lang="en-GB" sz="1400" dirty="0"/>
-              <a:t>Restructured Service Disruption Section:</a:t>
-            </a:r>
-          </a:p>
-          <a:p>
-            <a:pPr lvl="2">
-              <a:spcBef>
-                <a:spcPts val="225"/>
-              </a:spcBef>
-              <a:spcAft>
-                <a:spcPts val="225"/>
-              </a:spcAft>
-              <a:buFontTx/>
-              <a:buChar char="-"/>
-            </a:pPr>
-            <a:r>
-              <a:rPr lang="en-GB" sz="1400" dirty="0"/>
-              <a:t>Added sections on Knowledge Based and detailed it with subsections including Expert Rules, Network Modelling, Data Profiling, and Detection Strategies. </a:t>
-            </a:r>
-          </a:p>
-          <a:p>
-            <a:pPr lvl="2">
-              <a:spcBef>
-                <a:spcPts val="225"/>
-              </a:spcBef>
-              <a:spcAft>
-                <a:spcPts val="225"/>
-              </a:spcAft>
-              <a:buFontTx/>
-              <a:buChar char="-"/>
-            </a:pPr>
-            <a:r>
-              <a:rPr lang="en-GB" sz="1400" dirty="0"/>
-              <a:t>ML part moved to "Conventions" &amp; "Data Profiling”</a:t>
-            </a:r>
-          </a:p>
-          <a:p>
-            <a:pPr>
-              <a:spcBef>
-                <a:spcPts val="225"/>
-              </a:spcBef>
-              <a:spcAft>
-                <a:spcPts val="225"/>
-              </a:spcAft>
-            </a:pPr>
-            <a:r>
-              <a:rPr lang="en-GB" sz="1400" b="1" dirty="0"/>
-              <a:t>Refinement</a:t>
-            </a:r>
-          </a:p>
-          <a:p>
-            <a:pPr lvl="1"/>
-            <a:r>
-              <a:rPr lang="en-GB" sz="1400" dirty="0"/>
-              <a:t>Formalized the relationship between Semantic, Rule, &amp; Knowledge-based detection.</a:t>
-            </a:r>
-          </a:p>
-          <a:p>
-            <a:pPr lvl="1"/>
-            <a:r>
-              <a:rPr lang="en-GB" sz="1400" dirty="0"/>
-              <a:t>Refined definition: collective outlier, confidence score, concern score. </a:t>
-            </a:r>
-          </a:p>
-          <a:p>
-            <a:pPr lvl="1"/>
-            <a:r>
-              <a:rPr lang="en-GB" sz="1400" dirty="0"/>
-              <a:t>Refined clarification: Alarm-raising criteria, Data Storage Considerations, Operational Data Aggregation</a:t>
-            </a:r>
-          </a:p>
-          <a:p>
-            <a:r>
-              <a:rPr lang="en-GB" sz="1400" dirty="0"/>
-              <a:t> Out-scoping Service Degradation based on </a:t>
-            </a:r>
-            <a:r>
-              <a:rPr lang="en-US" sz="1400" dirty="0"/>
-              <a:t>Rüdiger Geib</a:t>
-            </a:r>
-            <a:r>
-              <a:rPr lang="en-GB" sz="1400" dirty="0"/>
-              <a:t>’s comment</a:t>
+              <a:t>Key draft updates since v-05</a:t>
             </a:r>
           </a:p>
         </p:txBody>
@@ -8066,7 +8217,7 @@
           <a:p>
             <a:fld id="{D89484F6-4B41-9E41-A6A3-57B4ED278EE2}" type="datetime1">
               <a:rPr lang="de-CH" smtClean="0"/>
-              <a:t>06.03.2026</a:t>
+              <a:t>06.03.26</a:t>
             </a:fld>
             <a:endParaRPr lang="en-US"/>
           </a:p>
@@ -8111,6 +8262,14 @@
   <p:clrMapOvr>
     <a:masterClrMapping/>
   </p:clrMapOvr>
+  <mc:AlternateContent xmlns:mc="http://schemas.openxmlformats.org/markup-compatibility/2006">
+    <mc:Choice xmlns:p14="http://schemas.microsoft.com/office/powerpoint/2010/main" Requires="p14">
+      <p:transition spd="slow" p14:dur="2000" advTm="7225"/>
+    </mc:Choice>
+    <mc:Fallback>
+      <p:transition spd="slow" advTm="7225"/>
+    </mc:Fallback>
+  </mc:AlternateContent>
 </p:sld>
 </file>
 
@@ -8318,7 +8477,7 @@
           <a:p>
             <a:fld id="{424BBBEE-3E14-134E-8436-66BE949C590A}" type="datetime1">
               <a:rPr lang="de-CH" smtClean="0"/>
-              <a:t>06.03.2026</a:t>
+              <a:t>06.03.26</a:t>
             </a:fld>
             <a:endParaRPr lang="en-US"/>
           </a:p>
@@ -8649,7 +8808,7 @@
           <a:p>
             <a:fld id="{424BBBEE-3E14-134E-8436-66BE949C590A}" type="datetime1">
               <a:rPr lang="de-CH" smtClean="0"/>
-              <a:t>06.03.2026</a:t>
+              <a:t>06.03.26</a:t>
             </a:fld>
             <a:endParaRPr lang="en-US"/>
           </a:p>
@@ -8932,17 +9091,19 @@
             </a:lvl9pPr>
           </a:lstStyle>
           <a:p>
-            <a:pPr>
+            <a:pPr marL="171450" indent="-171450">
               <a:spcBef>
                 <a:spcPts val="300"/>
               </a:spcBef>
               <a:spcAft>
                 <a:spcPts val="300"/>
               </a:spcAft>
+              <a:buFont typeface="Arial" panose="020B0604020202020204" pitchFamily="34" charset="0"/>
+              <a:buChar char="•"/>
             </a:pPr>
             <a:r>
               <a:rPr lang="en-US" sz="1200" b="1" dirty="0"/>
-              <a:t>BMP route-monitoring Update/Withdraw check recognized </a:t>
+              <a:t>BMP route-monitoring Update/Withdraw check detected </a:t>
             </a:r>
             <a:r>
               <a:rPr lang="en-US" sz="1200" b="1" dirty="0">
@@ -8962,7 +9123,7 @@
                   <a:srgbClr val="FF0000"/>
                 </a:solidFill>
               </a:rPr>
-              <a:t>excessive topology changes </a:t>
+              <a:t>excessive routing topology changes </a:t>
             </a:r>
             <a:r>
               <a:rPr lang="en-US" sz="1200" b="1" dirty="0"/>
@@ -8970,13 +9131,15 @@
             </a:r>
           </a:p>
           <a:p>
-            <a:pPr>
+            <a:pPr marL="171450" indent="-171450">
               <a:spcBef>
                 <a:spcPts val="300"/>
               </a:spcBef>
               <a:spcAft>
                 <a:spcPts val="300"/>
               </a:spcAft>
+              <a:buFont typeface="Arial" panose="020B0604020202020204" pitchFamily="34" charset="0"/>
+              <a:buChar char="•"/>
             </a:pPr>
             <a:r>
               <a:rPr lang="en-US" sz="1200" dirty="0"/>
@@ -8985,13 +9148,15 @@
             <a:endParaRPr lang="en-US" sz="1200" b="1" dirty="0"/>
           </a:p>
           <a:p>
-            <a:pPr>
+            <a:pPr marL="171450" indent="-171450">
               <a:spcBef>
                 <a:spcPts val="300"/>
               </a:spcBef>
               <a:spcAft>
                 <a:spcPts val="300"/>
               </a:spcAft>
+              <a:buFont typeface="Arial" panose="020B0604020202020204" pitchFamily="34" charset="0"/>
+              <a:buChar char="•"/>
             </a:pPr>
             <a:r>
               <a:rPr lang="en-US" sz="1200" dirty="0"/>
@@ -8999,13 +9164,15 @@
             </a:r>
           </a:p>
           <a:p>
-            <a:pPr>
+            <a:pPr marL="171450" indent="-171450">
               <a:spcBef>
                 <a:spcPts val="300"/>
               </a:spcBef>
               <a:spcAft>
                 <a:spcPts val="300"/>
               </a:spcAft>
+              <a:buFont typeface="Arial" panose="020B0604020202020204" pitchFamily="34" charset="0"/>
+              <a:buChar char="•"/>
             </a:pPr>
             <a:r>
               <a:rPr lang="en-US" sz="1200" b="1" dirty="0"/>
@@ -9013,13 +9180,15 @@
             </a:r>
           </a:p>
           <a:p>
-            <a:pPr>
+            <a:pPr marL="171450" indent="-171450">
               <a:spcBef>
                 <a:spcPts val="300"/>
               </a:spcBef>
               <a:spcAft>
                 <a:spcPts val="300"/>
               </a:spcAft>
+              <a:buFont typeface="Arial" panose="020B0604020202020204" pitchFamily="34" charset="0"/>
+              <a:buChar char="•"/>
             </a:pPr>
             <a:r>
               <a:rPr lang="en-US" sz="1200" b="1" dirty="0"/>
@@ -9027,7 +9196,7 @@
             </a:r>
             <a:r>
               <a:rPr lang="en-US" sz="1200" dirty="0"/>
-              <a:t>recognized.</a:t>
+              <a:t>detected.</a:t>
             </a:r>
             <a:endParaRPr lang="en-US" sz="1200" dirty="0">
               <a:solidFill>
@@ -9036,6 +9205,22 @@
             </a:endParaRPr>
           </a:p>
           <a:p>
+            <a:pPr marL="171450" indent="-171450">
+              <a:spcBef>
+                <a:spcPts val="300"/>
+              </a:spcBef>
+              <a:spcAft>
+                <a:spcPts val="300"/>
+              </a:spcAft>
+              <a:buFont typeface="Arial" panose="020B0604020202020204" pitchFamily="34" charset="0"/>
+              <a:buChar char="•"/>
+            </a:pPr>
+            <a:r>
+              <a:rPr lang="en-US" sz="1200" dirty="0"/>
+              <a:t>Sudden increased or decreased Flow Count was not applicable.</a:t>
+            </a:r>
+          </a:p>
+          <a:p>
             <a:pPr>
               <a:spcBef>
                 <a:spcPts val="300"/>
@@ -9044,10 +9229,7 @@
                 <a:spcPts val="300"/>
               </a:spcAft>
             </a:pPr>
-            <a:r>
-              <a:rPr lang="en-US" sz="1200" dirty="0"/>
-              <a:t>Sudden increased or decreased Flow Count was not applicable.</a:t>
-            </a:r>
+            <a:endParaRPr lang="en-US" sz="1200" b="1" dirty="0"/>
           </a:p>
           <a:p>
             <a:pPr>
@@ -9600,52 +9782,48 @@
               <a:buNone/>
             </a:pPr>
             <a:r>
-              <a:rPr lang="en-GB" sz="1600"/>
+              <a:rPr lang="en-GB" sz="1600" dirty="0"/>
               <a:t>To facilitate the </a:t>
             </a:r>
             <a:r>
-              <a:rPr lang="en-GB" sz="1600" b="1"/>
+              <a:rPr lang="en-GB" sz="1600" b="1" dirty="0"/>
               <a:t>exchange</a:t>
             </a:r>
             <a:r>
-              <a:rPr lang="en-GB" sz="1600"/>
+              <a:rPr lang="en-GB" sz="1600" dirty="0"/>
               <a:t> of network anomaly data across diverse systems, and </a:t>
             </a:r>
             <a:r>
-              <a:rPr lang="en-GB" sz="1600" b="1"/>
+              <a:rPr lang="en-GB" sz="1600" b="1" dirty="0"/>
               <a:t>benchmarking</a:t>
             </a:r>
             <a:r>
-              <a:rPr lang="en-GB" sz="1600"/>
+              <a:rPr lang="en-GB" sz="1600" dirty="0"/>
               <a:t> of various anomaly detection systems, this draft defines a </a:t>
             </a:r>
             <a:r>
-              <a:rPr lang="en-GB" sz="1600" b="1"/>
+              <a:rPr lang="en-GB" sz="1600" b="1" dirty="0"/>
               <a:t>standardized semantic metadata schema </a:t>
             </a:r>
             <a:r>
-              <a:rPr lang="en-GB" sz="1600"/>
+              <a:rPr lang="en-GB" sz="1600" dirty="0"/>
               <a:t>and</a:t>
             </a:r>
             <a:r>
-              <a:rPr lang="en-GB" sz="1600" b="1"/>
+              <a:rPr lang="en-GB" sz="1600" b="1" dirty="0"/>
               <a:t> </a:t>
             </a:r>
             <a:r>
-              <a:rPr lang="en-GB" sz="1600"/>
+              <a:rPr lang="en-GB" sz="1600" dirty="0"/>
               <a:t>a set of </a:t>
             </a:r>
             <a:r>
-              <a:rPr lang="en-GB" sz="1600" b="1"/>
+              <a:rPr lang="en-GB" sz="1600" b="1" dirty="0"/>
               <a:t>semantically structured terms </a:t>
             </a:r>
             <a:r>
-              <a:rPr lang="en-GB" sz="1600"/>
-              <a:t>that provides human-readable context for network anomalies</a:t>
-            </a:r>
-            <a:r>
               <a:rPr lang="en-GB" sz="1600" dirty="0"/>
-              <a:t>.</a:t>
+              <a:t>that provide human-readable context for network anomalies.</a:t>
             </a:r>
           </a:p>
         </p:txBody>
@@ -9673,7 +9851,7 @@
           <a:p>
             <a:fld id="{0772E8C7-46E4-2945-98F0-FAB6CBA5DC8E}" type="datetime1">
               <a:rPr lang="de-CH" smtClean="0"/>
-              <a:t>06.03.2026</a:t>
+              <a:t>06.03.26</a:t>
             </a:fld>
             <a:endParaRPr lang="en-US"/>
           </a:p>
@@ -9813,7 +9991,7 @@
                   </a:schemeClr>
                 </a:solidFill>
               </a:rPr>
-              <a:t>Key draft updates since -03</a:t>
+              <a:t>Key draft updates since v-03</a:t>
             </a:r>
           </a:p>
         </p:txBody>
@@ -10486,7 +10664,7 @@
           <a:p>
             <a:fld id="{F9F3D982-4073-1C4A-9ED7-B56D2EA5D830}" type="datetime1">
               <a:rPr lang="de-CH" smtClean="0"/>
-              <a:t>06.03.2026</a:t>
+              <a:t>06.03.26</a:t>
             </a:fld>
             <a:endParaRPr lang="en-US"/>
           </a:p>
@@ -10558,10 +10736,9 @@
               </a:spcAft>
             </a:pPr>
             <a:r>
-              <a:rPr lang="en-US" sz="1400" b="1"/>
+              <a:rPr lang="en-US" sz="1400" b="1" dirty="0"/>
               <a:t>Terminology update</a:t>
             </a:r>
-            <a:endParaRPr lang="en-US" sz="1400" b="1" dirty="0"/>
           </a:p>
           <a:p>
             <a:pPr lvl="1">
@@ -10573,7 +10750,7 @@
               </a:spcAft>
             </a:pPr>
             <a:r>
-              <a:rPr lang="en-GB" sz="1400"/>
+              <a:rPr lang="en-GB" sz="1400" dirty="0"/>
               <a:t>Added missing definition of terminologies used in the draft such as concern score and symptom</a:t>
             </a:r>
             <a:r>
@@ -10591,10 +10768,9 @@
               </a:spcAft>
             </a:pPr>
             <a:r>
-              <a:rPr lang="en-US" sz="1400" b="1"/>
+              <a:rPr lang="en-US" sz="1400" b="1" dirty="0"/>
               <a:t>Schema change</a:t>
             </a:r>
-            <a:endParaRPr lang="en-US" sz="1400" b="1" dirty="0"/>
           </a:p>
           <a:p>
             <a:pPr lvl="1">
@@ -10608,10 +10784,9 @@
               <a:buChar char="-"/>
             </a:pPr>
             <a:r>
-              <a:rPr lang="en-GB" sz="1400"/>
+              <a:rPr lang="en-GB" sz="1400" dirty="0"/>
               <a:t>Removed unused typedef score</a:t>
             </a:r>
-            <a:endParaRPr lang="en-GB" sz="1400" dirty="0"/>
           </a:p>
           <a:p>
             <a:pPr lvl="1">
@@ -10625,10 +10800,17 @@
               <a:buChar char="-"/>
             </a:pPr>
             <a:r>
-              <a:rPr lang="en-GB" sz="1400"/>
-              <a:t>Changed vpn-node-termination</a:t>
-            </a:r>
-            <a:endParaRPr lang="en-GB" sz="1400" dirty="0"/>
+              <a:rPr lang="en-GB" sz="1400" dirty="0"/>
+              <a:t>Refined </a:t>
+            </a:r>
+            <a:r>
+              <a:rPr lang="en-GB" sz="1400" dirty="0" err="1"/>
+              <a:t>vpn</a:t>
+            </a:r>
+            <a:r>
+              <a:rPr lang="en-GB" sz="1400" dirty="0"/>
+              <a:t>-node-termination</a:t>
+            </a:r>
           </a:p>
           <a:p>
             <a:pPr lvl="1">
@@ -10642,10 +10824,9 @@
               <a:buChar char="-"/>
             </a:pPr>
             <a:r>
-              <a:rPr lang="en-GB" sz="1400"/>
+              <a:rPr lang="en-GB" sz="1400" dirty="0"/>
               <a:t>Introduced dedicated L2&amp;L3 groupings for service</a:t>
             </a:r>
-            <a:endParaRPr lang="en-GB" sz="1400" dirty="0"/>
           </a:p>
           <a:p>
             <a:pPr>
@@ -10657,28 +10838,22 @@
               </a:spcAft>
             </a:pPr>
             <a:r>
-              <a:rPr lang="en-GB" sz="1400" b="1"/>
+              <a:rPr lang="en-GB" sz="1400" b="1" dirty="0"/>
               <a:t>Symptom table update</a:t>
             </a:r>
-            <a:endParaRPr lang="en-GB" sz="1400" b="1" dirty="0"/>
           </a:p>
           <a:p>
             <a:pPr lvl="1"/>
             <a:r>
-              <a:rPr lang="en-GB" sz="1400"/>
-              <a:t>Update symptom: reason “Previous” -&gt; “Drop”, trigger “Time” -&gt; “Outside Monitored Domain</a:t>
-            </a:r>
-            <a:r>
               <a:rPr lang="en-GB" sz="1400" dirty="0"/>
-              <a:t>”</a:t>
-            </a:r>
-          </a:p>
-          <a:p>
-            <a:r>
-              <a:rPr lang="en-GB" sz="1400"/>
+              <a:t>Update symptom: reason “Previous” -&gt; “Drop”, trigger “Time” -&gt; “Outside Monitored Domain”</a:t>
+            </a:r>
+          </a:p>
+          <a:p>
+            <a:r>
+              <a:rPr lang="en-GB" sz="1400" dirty="0"/>
               <a:t>Avro schema changed accordingly</a:t>
             </a:r>
-            <a:endParaRPr lang="en-GB" sz="1400" dirty="0"/>
           </a:p>
         </p:txBody>
       </p:sp>
@@ -10979,7 +11154,7 @@
           <a:p>
             <a:fld id="{C3D18FEC-DBD4-214C-B3C5-65378705016C}" type="datetime1">
               <a:rPr lang="de-CH" smtClean="0"/>
-              <a:t>06.03.2026</a:t>
+              <a:t>06.03.26</a:t>
             </a:fld>
             <a:endParaRPr lang="en-US"/>
           </a:p>
@@ -12298,8 +12473,8 @@
         </p:nvSpPr>
         <p:spPr>
           <a:xfrm>
-            <a:off x="6222381" y="1608157"/>
-            <a:ext cx="2582088" cy="523220"/>
+            <a:off x="6104712" y="1448357"/>
+            <a:ext cx="2582088" cy="738664"/>
           </a:xfrm>
           <a:prstGeom prst="rect">
             <a:avLst/>
@@ -12314,7 +12489,7 @@
           <a:p>
             <a:r>
               <a:rPr lang="en-US" sz="1400" dirty="0"/>
-              <a:t>‼️ Only schema was updated, metadata not yet ready.</a:t>
+              <a:t>*Only the schema has been updated. Operational metadata population not yet implemented.</a:t>
             </a:r>
             <a:endParaRPr lang="en-CH" sz="1400" dirty="0"/>
           </a:p>
@@ -13321,10 +13496,4 @@
   <we:bindings/>
   <we:snapshot xmlns:r="http://schemas.openxmlformats.org/officeDocument/2006/relationships"/>
 </we:webextension>
-</file>
-
-<file path=docMetadata/LabelInfo.xml><?xml version="1.0" encoding="utf-8"?>
-<clbl:labelList xmlns:clbl="http://schemas.microsoft.com/office/2020/mipLabelMetadata">
-  <clbl:label id="{2e1fccfb-80ca-4fe1-a574-1516544edb53}" enabled="1" method="Standard" siteId="{364e5b87-c1c7-420d-9bee-c35d19b557a1}" removed="0"/>
-</clbl:labelList>
 </file>
</xml_diff>

<commit_message>
update anomaly detection slides: bullet points, update date, etc
</commit_message>
<xml_diff>
--- a/125/NMOP/draft-ietf-nmop-network-anomaly-architecture-semantics-lifecycle.pptx
+++ b/125/NMOP/draft-ietf-nmop-network-anomaly-architecture-semantics-lifecycle.pptx
@@ -266,7 +266,7 @@
           <a:p>
             <a:fld id="{6C04DF18-294A-1942-9DCF-44575627E94A}" type="datetimeFigureOut">
               <a:rPr lang="en-CH" smtClean="0"/>
-              <a:t>12.03.2026</a:t>
+              <a:t>14.03.2026</a:t>
             </a:fld>
             <a:endParaRPr lang="en-CH"/>
           </a:p>
@@ -443,7 +443,7 @@
           <a:p>
             <a:fld id="{773D56C8-71B6-624F-AE43-15F6568A2909}" type="datetimeFigureOut">
               <a:rPr lang="en-CH" smtClean="0"/>
-              <a:t>12.03.2026</a:t>
+              <a:t>14.03.2026</a:t>
             </a:fld>
             <a:endParaRPr lang="en-CH"/>
           </a:p>
@@ -755,14 +755,6 @@
           <a:bodyPr/>
           <a:lstStyle/>
           <a:p>
-            <a:r>
-              <a:rPr lang="en-CH" dirty="0"/>
-              <a:t>Out-scoping: </a:t>
-            </a:r>
-            <a:r>
-              <a:rPr lang="en-US" sz="1200" dirty="0"/>
-              <a:t>Rüdiger Geib</a:t>
-            </a:r>
             <a:endParaRPr lang="en-CH" dirty="0"/>
           </a:p>
         </p:txBody>
@@ -784,7 +776,7 @@
           <a:p>
             <a:fld id="{4C0DE7E3-6817-D34F-9F2D-16E920BB51A9}" type="slidenum">
               <a:rPr lang="en-CH" smtClean="0"/>
-              <a:t>5</a:t>
+              <a:t>1</a:t>
             </a:fld>
             <a:endParaRPr lang="en-CH"/>
           </a:p>
@@ -793,7 +785,7 @@
     </p:spTree>
     <p:extLst>
       <p:ext uri="{BB962C8B-B14F-4D97-AF65-F5344CB8AC3E}">
-        <p14:creationId xmlns:p14="http://schemas.microsoft.com/office/powerpoint/2010/main" val="4110580975"/>
+        <p14:creationId xmlns:p14="http://schemas.microsoft.com/office/powerpoint/2010/main" val="3594752714"/>
       </p:ext>
     </p:extLst>
   </p:cSld>
@@ -847,78 +839,6 @@
           <a:bodyPr/>
           <a:lstStyle/>
           <a:p>
-            <a:pPr marL="0" marR="0" lvl="0" indent="0" algn="l" defTabSz="914400" rtl="0" eaLnBrk="1" fontAlgn="auto" latinLnBrk="0" hangingPunct="1">
-              <a:lnSpc>
-                <a:spcPct val="100000"/>
-              </a:lnSpc>
-              <a:spcBef>
-                <a:spcPts val="0"/>
-              </a:spcBef>
-              <a:spcAft>
-                <a:spcPts val="0"/>
-              </a:spcAft>
-              <a:buClrTx/>
-              <a:buSzTx/>
-              <a:buFontTx/>
-              <a:buNone/>
-              <a:tabLst/>
-              <a:defRPr/>
-            </a:pPr>
-            <a:r>
-              <a:rPr lang="en-GB" dirty="0"/>
-              <a:t>Our Blue TV service is currently severely impaired. Both the Blue TV‐boxes and TV Air on the web and in the Blue TV app are affected. When switching on the TV‐ Box, our customers receive an error message. Restarting the TV‐Box does not resolve the fault.</a:t>
-            </a:r>
-            <a:br>
-              <a:rPr lang="en-GB" dirty="0"/>
-            </a:br>
-            <a:r>
-              <a:rPr lang="en-GB" dirty="0"/>
-              <a:t>Root cause: 2 physical servers crashed in one of the 2 </a:t>
-            </a:r>
-            <a:r>
-              <a:rPr lang="en-GB" dirty="0" err="1"/>
-              <a:t>redis</a:t>
-            </a:r>
-            <a:r>
-              <a:rPr lang="en-GB" dirty="0"/>
-              <a:t> clusters, which puts Redis cluster in to an unstable state -&gt; re-authentication new connection burst (</a:t>
-            </a:r>
-            <a:r>
-              <a:rPr lang="en-GB" sz="1200" b="0" i="0" kern="1200" dirty="0">
-                <a:solidFill>
-                  <a:schemeClr val="tx1"/>
-                </a:solidFill>
-                <a:effectLst/>
-                <a:latin typeface="+mn-lt"/>
-                <a:ea typeface="+mn-ea"/>
-                <a:cs typeface="+mn-cs"/>
-              </a:rPr>
-              <a:t>Connection timeouts were incorrect</a:t>
-            </a:r>
-          </a:p>
-          <a:p>
-            <a:r>
-              <a:rPr lang="en-GB" dirty="0"/>
-              <a:t>) -&gt; Denial-of-Service </a:t>
-            </a:r>
-            <a:r>
-              <a:rPr lang="en-GB" dirty="0">
-                <a:sym typeface="Wingdings" pitchFamily="2" charset="2"/>
-              </a:rPr>
-              <a:t> the secondary </a:t>
-            </a:r>
-            <a:r>
-              <a:rPr lang="en-GB" dirty="0" err="1">
-                <a:sym typeface="Wingdings" pitchFamily="2" charset="2"/>
-              </a:rPr>
-              <a:t>redis</a:t>
-            </a:r>
-            <a:r>
-              <a:rPr lang="en-GB" dirty="0">
-                <a:sym typeface="Wingdings" pitchFamily="2" charset="2"/>
-              </a:rPr>
-              <a:t> cluster also failed</a:t>
-            </a:r>
             <a:endParaRPr lang="en-CH" dirty="0"/>
           </a:p>
         </p:txBody>
@@ -940,7 +860,7 @@
           <a:p>
             <a:fld id="{4C0DE7E3-6817-D34F-9F2D-16E920BB51A9}" type="slidenum">
               <a:rPr lang="en-CH" smtClean="0"/>
-              <a:t>6</a:t>
+              <a:t>4</a:t>
             </a:fld>
             <a:endParaRPr lang="en-CH"/>
           </a:p>
@@ -949,7 +869,7 @@
     </p:spTree>
     <p:extLst>
       <p:ext uri="{BB962C8B-B14F-4D97-AF65-F5344CB8AC3E}">
-        <p14:creationId xmlns:p14="http://schemas.microsoft.com/office/powerpoint/2010/main" val="2119585509"/>
+        <p14:creationId xmlns:p14="http://schemas.microsoft.com/office/powerpoint/2010/main" val="89408563"/>
       </p:ext>
     </p:extLst>
   </p:cSld>
@@ -964,13 +884,7 @@
   <p:cSld>
     <p:spTree>
       <p:nvGrpSpPr>
-        <p:cNvPr id="1" name="">
-          <a:extLst>
-            <a:ext uri="{FF2B5EF4-FFF2-40B4-BE49-F238E27FC236}">
-              <a16:creationId xmlns:a16="http://schemas.microsoft.com/office/drawing/2014/main" id="{9566F8C3-9A5E-3CC2-1C97-EC9904582156}"/>
-            </a:ext>
-          </a:extLst>
-        </p:cNvPr>
+        <p:cNvPr id="1" name=""/>
         <p:cNvGrpSpPr/>
         <p:nvPr/>
       </p:nvGrpSpPr>
@@ -984,13 +898,7 @@
       </p:grpSpPr>
       <p:sp>
         <p:nvSpPr>
-          <p:cNvPr id="2" name="Slide Image Placeholder 1">
-            <a:extLst>
-              <a:ext uri="{FF2B5EF4-FFF2-40B4-BE49-F238E27FC236}">
-                <a16:creationId xmlns:a16="http://schemas.microsoft.com/office/drawing/2014/main" id="{AC495C7A-43AB-8E51-EDFA-25D60B00AFDF}"/>
-              </a:ext>
-            </a:extLst>
-          </p:cNvPr>
+          <p:cNvPr id="2" name="Slide Image Placeholder 1"/>
           <p:cNvSpPr>
             <a:spLocks noGrp="1" noRot="1" noChangeAspect="1"/>
           </p:cNvSpPr>
@@ -1002,13 +910,7 @@
       </p:sp>
       <p:sp>
         <p:nvSpPr>
-          <p:cNvPr id="3" name="Notes Placeholder 2">
-            <a:extLst>
-              <a:ext uri="{FF2B5EF4-FFF2-40B4-BE49-F238E27FC236}">
-                <a16:creationId xmlns:a16="http://schemas.microsoft.com/office/drawing/2014/main" id="{AD40FC28-8E31-FFEF-A4BA-3D1359514EBB}"/>
-              </a:ext>
-            </a:extLst>
-          </p:cNvPr>
+          <p:cNvPr id="3" name="Notes Placeholder 2"/>
           <p:cNvSpPr>
             <a:spLocks noGrp="1"/>
           </p:cNvSpPr>
@@ -1021,77 +923,13 @@
           <a:bodyPr/>
           <a:lstStyle/>
           <a:p>
-            <a:pPr marL="0" marR="0" lvl="0" indent="0" algn="l" defTabSz="914400" rtl="0" eaLnBrk="1" fontAlgn="auto" latinLnBrk="0" hangingPunct="1">
-              <a:lnSpc>
-                <a:spcPct val="100000"/>
-              </a:lnSpc>
-              <a:spcBef>
-                <a:spcPts val="0"/>
-              </a:spcBef>
-              <a:spcAft>
-                <a:spcPts val="0"/>
-              </a:spcAft>
-              <a:buClrTx/>
-              <a:buSzTx/>
-              <a:buFontTx/>
-              <a:buNone/>
-              <a:tabLst/>
-              <a:defRPr/>
-            </a:pPr>
-            <a:r>
-              <a:rPr lang="en-GB" dirty="0"/>
-              <a:t>Our Blue TV service is currently severely impaired. Both the Blue TV‐boxes and TV Air on the web and in the Blue TV app are affected. When switching on the TV‐ Box, our customers receive an error message. Restarting the TV‐Box does not resolve the fault.</a:t>
-            </a:r>
-            <a:br>
-              <a:rPr lang="en-GB" dirty="0"/>
-            </a:br>
-            <a:r>
-              <a:rPr lang="en-GB" dirty="0"/>
-              <a:t>Root cause: 2 physical servers crashed in one of the 2 </a:t>
-            </a:r>
-            <a:r>
-              <a:rPr lang="en-GB" dirty="0" err="1"/>
-              <a:t>redis</a:t>
-            </a:r>
-            <a:r>
-              <a:rPr lang="en-GB" dirty="0"/>
-              <a:t> clusters, which puts Redis cluster into an unstable state -&gt; re-authentication new connection burst (</a:t>
-            </a:r>
-            <a:r>
-              <a:rPr lang="en-GB" sz="1200" b="0" i="0" kern="1200" dirty="0">
-                <a:solidFill>
-                  <a:schemeClr val="tx1"/>
-                </a:solidFill>
-                <a:effectLst/>
-                <a:latin typeface="+mn-lt"/>
-                <a:ea typeface="+mn-ea"/>
-                <a:cs typeface="+mn-cs"/>
-              </a:rPr>
-              <a:t>Connection timeouts were incorrect</a:t>
-            </a:r>
-          </a:p>
-          <a:p>
-            <a:r>
-              <a:rPr lang="en-GB" dirty="0"/>
-              <a:t>) -&gt; Denial-of-Service </a:t>
-            </a:r>
-            <a:r>
-              <a:rPr lang="en-GB" dirty="0">
-                <a:sym typeface="Wingdings" pitchFamily="2" charset="2"/>
-              </a:rPr>
-              <a:t> the secondary </a:t>
-            </a:r>
-            <a:r>
-              <a:rPr lang="en-GB" dirty="0" err="1">
-                <a:sym typeface="Wingdings" pitchFamily="2" charset="2"/>
-              </a:rPr>
-              <a:t>redis</a:t>
-            </a:r>
-            <a:r>
-              <a:rPr lang="en-GB" dirty="0">
-                <a:sym typeface="Wingdings" pitchFamily="2" charset="2"/>
-              </a:rPr>
-              <a:t> cluster also failed</a:t>
+            <a:r>
+              <a:rPr lang="en-CH" dirty="0"/>
+              <a:t>Out-scoping: </a:t>
+            </a:r>
+            <a:r>
+              <a:rPr lang="en-US" sz="1200" dirty="0"/>
+              <a:t>Rüdiger Geib</a:t>
             </a:r>
             <a:endParaRPr lang="en-CH" dirty="0"/>
           </a:p>
@@ -1099,13 +937,7 @@
       </p:sp>
       <p:sp>
         <p:nvSpPr>
-          <p:cNvPr id="4" name="Slide Number Placeholder 3">
-            <a:extLst>
-              <a:ext uri="{FF2B5EF4-FFF2-40B4-BE49-F238E27FC236}">
-                <a16:creationId xmlns:a16="http://schemas.microsoft.com/office/drawing/2014/main" id="{A3CE2A89-4A22-E043-71C1-15575779D375}"/>
-              </a:ext>
-            </a:extLst>
-          </p:cNvPr>
+          <p:cNvPr id="4" name="Slide Number Placeholder 3"/>
           <p:cNvSpPr>
             <a:spLocks noGrp="1"/>
           </p:cNvSpPr>
@@ -1120,7 +952,7 @@
           <a:p>
             <a:fld id="{4C0DE7E3-6817-D34F-9F2D-16E920BB51A9}" type="slidenum">
               <a:rPr lang="en-CH" smtClean="0"/>
-              <a:t>7</a:t>
+              <a:t>5</a:t>
             </a:fld>
             <a:endParaRPr lang="en-CH"/>
           </a:p>
@@ -1129,7 +961,7 @@
     </p:spTree>
     <p:extLst>
       <p:ext uri="{BB962C8B-B14F-4D97-AF65-F5344CB8AC3E}">
-        <p14:creationId xmlns:p14="http://schemas.microsoft.com/office/powerpoint/2010/main" val="688627969"/>
+        <p14:creationId xmlns:p14="http://schemas.microsoft.com/office/powerpoint/2010/main" val="4110580975"/>
       </p:ext>
     </p:extLst>
   </p:cSld>
@@ -1183,6 +1015,342 @@
           <a:bodyPr/>
           <a:lstStyle/>
           <a:p>
+            <a:pPr marL="0" marR="0" lvl="0" indent="0" algn="l" defTabSz="914400" rtl="0" eaLnBrk="1" fontAlgn="auto" latinLnBrk="0" hangingPunct="1">
+              <a:lnSpc>
+                <a:spcPct val="100000"/>
+              </a:lnSpc>
+              <a:spcBef>
+                <a:spcPts val="0"/>
+              </a:spcBef>
+              <a:spcAft>
+                <a:spcPts val="0"/>
+              </a:spcAft>
+              <a:buClrTx/>
+              <a:buSzTx/>
+              <a:buFontTx/>
+              <a:buNone/>
+              <a:tabLst/>
+              <a:defRPr/>
+            </a:pPr>
+            <a:r>
+              <a:rPr lang="en-GB" dirty="0"/>
+              <a:t>Our Blue TV service is currently severely impaired. Both the Blue TV‐boxes and TV Air on the web and in the Blue TV app are affected. When switching on the TV‐ Box, our customers receive an error message. Restarting the TV‐Box does not resolve the fault.</a:t>
+            </a:r>
+            <a:br>
+              <a:rPr lang="en-GB" dirty="0"/>
+            </a:br>
+            <a:r>
+              <a:rPr lang="en-GB" dirty="0"/>
+              <a:t>Root cause: 2 physical servers crashed in one of the 2 </a:t>
+            </a:r>
+            <a:r>
+              <a:rPr lang="en-GB" dirty="0" err="1"/>
+              <a:t>redis</a:t>
+            </a:r>
+            <a:r>
+              <a:rPr lang="en-GB" dirty="0"/>
+              <a:t> clusters, which puts Redis cluster in to an unstable state -&gt; re-authentication new connection burst (</a:t>
+            </a:r>
+            <a:r>
+              <a:rPr lang="en-GB" sz="1200" b="0" i="0" kern="1200" dirty="0">
+                <a:solidFill>
+                  <a:schemeClr val="tx1"/>
+                </a:solidFill>
+                <a:effectLst/>
+                <a:latin typeface="+mn-lt"/>
+                <a:ea typeface="+mn-ea"/>
+                <a:cs typeface="+mn-cs"/>
+              </a:rPr>
+              <a:t>Connection timeouts were incorrect</a:t>
+            </a:r>
+          </a:p>
+          <a:p>
+            <a:r>
+              <a:rPr lang="en-GB" dirty="0"/>
+              <a:t>) -&gt; Denial-of-Service </a:t>
+            </a:r>
+            <a:r>
+              <a:rPr lang="en-GB" dirty="0">
+                <a:sym typeface="Wingdings" pitchFamily="2" charset="2"/>
+              </a:rPr>
+              <a:t> the secondary </a:t>
+            </a:r>
+            <a:r>
+              <a:rPr lang="en-GB" dirty="0" err="1">
+                <a:sym typeface="Wingdings" pitchFamily="2" charset="2"/>
+              </a:rPr>
+              <a:t>redis</a:t>
+            </a:r>
+            <a:r>
+              <a:rPr lang="en-GB" dirty="0">
+                <a:sym typeface="Wingdings" pitchFamily="2" charset="2"/>
+              </a:rPr>
+              <a:t> cluster also failed</a:t>
+            </a:r>
+            <a:endParaRPr lang="en-CH" dirty="0"/>
+          </a:p>
+        </p:txBody>
+      </p:sp>
+      <p:sp>
+        <p:nvSpPr>
+          <p:cNvPr id="4" name="Slide Number Placeholder 3"/>
+          <p:cNvSpPr>
+            <a:spLocks noGrp="1"/>
+          </p:cNvSpPr>
+          <p:nvPr>
+            <p:ph type="sldNum" sz="quarter" idx="5"/>
+          </p:nvPr>
+        </p:nvSpPr>
+        <p:spPr/>
+        <p:txBody>
+          <a:bodyPr/>
+          <a:lstStyle/>
+          <a:p>
+            <a:fld id="{4C0DE7E3-6817-D34F-9F2D-16E920BB51A9}" type="slidenum">
+              <a:rPr lang="en-CH" smtClean="0"/>
+              <a:t>6</a:t>
+            </a:fld>
+            <a:endParaRPr lang="en-CH"/>
+          </a:p>
+        </p:txBody>
+      </p:sp>
+    </p:spTree>
+    <p:extLst>
+      <p:ext uri="{BB962C8B-B14F-4D97-AF65-F5344CB8AC3E}">
+        <p14:creationId xmlns:p14="http://schemas.microsoft.com/office/powerpoint/2010/main" val="2119585509"/>
+      </p:ext>
+    </p:extLst>
+  </p:cSld>
+  <p:clrMapOvr>
+    <a:masterClrMapping/>
+  </p:clrMapOvr>
+</p:notes>
+</file>
+
+<file path=ppt/notesSlides/notesSlide5.xml><?xml version="1.0" encoding="utf-8"?>
+<p:notes xmlns:a="http://schemas.openxmlformats.org/drawingml/2006/main" xmlns:r="http://schemas.openxmlformats.org/officeDocument/2006/relationships" xmlns:p="http://schemas.openxmlformats.org/presentationml/2006/main">
+  <p:cSld>
+    <p:spTree>
+      <p:nvGrpSpPr>
+        <p:cNvPr id="1" name="">
+          <a:extLst>
+            <a:ext uri="{FF2B5EF4-FFF2-40B4-BE49-F238E27FC236}">
+              <a16:creationId xmlns:a16="http://schemas.microsoft.com/office/drawing/2014/main" id="{9566F8C3-9A5E-3CC2-1C97-EC9904582156}"/>
+            </a:ext>
+          </a:extLst>
+        </p:cNvPr>
+        <p:cNvGrpSpPr/>
+        <p:nvPr/>
+      </p:nvGrpSpPr>
+      <p:grpSpPr>
+        <a:xfrm>
+          <a:off x="0" y="0"/>
+          <a:ext cx="0" cy="0"/>
+          <a:chOff x="0" y="0"/>
+          <a:chExt cx="0" cy="0"/>
+        </a:xfrm>
+      </p:grpSpPr>
+      <p:sp>
+        <p:nvSpPr>
+          <p:cNvPr id="2" name="Slide Image Placeholder 1">
+            <a:extLst>
+              <a:ext uri="{FF2B5EF4-FFF2-40B4-BE49-F238E27FC236}">
+                <a16:creationId xmlns:a16="http://schemas.microsoft.com/office/drawing/2014/main" id="{AC495C7A-43AB-8E51-EDFA-25D60B00AFDF}"/>
+              </a:ext>
+            </a:extLst>
+          </p:cNvPr>
+          <p:cNvSpPr>
+            <a:spLocks noGrp="1" noRot="1" noChangeAspect="1"/>
+          </p:cNvSpPr>
+          <p:nvPr>
+            <p:ph type="sldImg"/>
+          </p:nvPr>
+        </p:nvSpPr>
+        <p:spPr/>
+      </p:sp>
+      <p:sp>
+        <p:nvSpPr>
+          <p:cNvPr id="3" name="Notes Placeholder 2">
+            <a:extLst>
+              <a:ext uri="{FF2B5EF4-FFF2-40B4-BE49-F238E27FC236}">
+                <a16:creationId xmlns:a16="http://schemas.microsoft.com/office/drawing/2014/main" id="{AD40FC28-8E31-FFEF-A4BA-3D1359514EBB}"/>
+              </a:ext>
+            </a:extLst>
+          </p:cNvPr>
+          <p:cNvSpPr>
+            <a:spLocks noGrp="1"/>
+          </p:cNvSpPr>
+          <p:nvPr>
+            <p:ph type="body" idx="1"/>
+          </p:nvPr>
+        </p:nvSpPr>
+        <p:spPr/>
+        <p:txBody>
+          <a:bodyPr/>
+          <a:lstStyle/>
+          <a:p>
+            <a:pPr marL="0" marR="0" lvl="0" indent="0" algn="l" defTabSz="914400" rtl="0" eaLnBrk="1" fontAlgn="auto" latinLnBrk="0" hangingPunct="1">
+              <a:lnSpc>
+                <a:spcPct val="100000"/>
+              </a:lnSpc>
+              <a:spcBef>
+                <a:spcPts val="0"/>
+              </a:spcBef>
+              <a:spcAft>
+                <a:spcPts val="0"/>
+              </a:spcAft>
+              <a:buClrTx/>
+              <a:buSzTx/>
+              <a:buFontTx/>
+              <a:buNone/>
+              <a:tabLst/>
+              <a:defRPr/>
+            </a:pPr>
+            <a:r>
+              <a:rPr lang="en-GB" dirty="0"/>
+              <a:t>Our Blue TV service is currently severely impaired. Both the Blue TV‐boxes and TV Air on the web and in the Blue TV app are affected. When switching on the TV‐ Box, our customers receive an error message. Restarting the TV‐Box does not resolve the fault.</a:t>
+            </a:r>
+            <a:br>
+              <a:rPr lang="en-GB" dirty="0"/>
+            </a:br>
+            <a:r>
+              <a:rPr lang="en-GB" dirty="0"/>
+              <a:t>Root cause: 2 physical servers crashed in one of the 2 </a:t>
+            </a:r>
+            <a:r>
+              <a:rPr lang="en-GB" dirty="0" err="1"/>
+              <a:t>redis</a:t>
+            </a:r>
+            <a:r>
+              <a:rPr lang="en-GB" dirty="0"/>
+              <a:t> clusters, which puts Redis cluster into an unstable state -&gt; re-authentication new connection burst (</a:t>
+            </a:r>
+            <a:r>
+              <a:rPr lang="en-GB" sz="1200" b="0" i="0" kern="1200" dirty="0">
+                <a:solidFill>
+                  <a:schemeClr val="tx1"/>
+                </a:solidFill>
+                <a:effectLst/>
+                <a:latin typeface="+mn-lt"/>
+                <a:ea typeface="+mn-ea"/>
+                <a:cs typeface="+mn-cs"/>
+              </a:rPr>
+              <a:t>Connection timeouts were incorrect</a:t>
+            </a:r>
+          </a:p>
+          <a:p>
+            <a:r>
+              <a:rPr lang="en-GB" dirty="0"/>
+              <a:t>) -&gt; Denial-of-Service </a:t>
+            </a:r>
+            <a:r>
+              <a:rPr lang="en-GB" dirty="0">
+                <a:sym typeface="Wingdings" pitchFamily="2" charset="2"/>
+              </a:rPr>
+              <a:t> the secondary </a:t>
+            </a:r>
+            <a:r>
+              <a:rPr lang="en-GB" dirty="0" err="1">
+                <a:sym typeface="Wingdings" pitchFamily="2" charset="2"/>
+              </a:rPr>
+              <a:t>redis</a:t>
+            </a:r>
+            <a:r>
+              <a:rPr lang="en-GB" dirty="0">
+                <a:sym typeface="Wingdings" pitchFamily="2" charset="2"/>
+              </a:rPr>
+              <a:t> cluster also failed</a:t>
+            </a:r>
+            <a:endParaRPr lang="en-CH" dirty="0"/>
+          </a:p>
+        </p:txBody>
+      </p:sp>
+      <p:sp>
+        <p:nvSpPr>
+          <p:cNvPr id="4" name="Slide Number Placeholder 3">
+            <a:extLst>
+              <a:ext uri="{FF2B5EF4-FFF2-40B4-BE49-F238E27FC236}">
+                <a16:creationId xmlns:a16="http://schemas.microsoft.com/office/drawing/2014/main" id="{A3CE2A89-4A22-E043-71C1-15575779D375}"/>
+              </a:ext>
+            </a:extLst>
+          </p:cNvPr>
+          <p:cNvSpPr>
+            <a:spLocks noGrp="1"/>
+          </p:cNvSpPr>
+          <p:nvPr>
+            <p:ph type="sldNum" sz="quarter" idx="5"/>
+          </p:nvPr>
+        </p:nvSpPr>
+        <p:spPr/>
+        <p:txBody>
+          <a:bodyPr/>
+          <a:lstStyle/>
+          <a:p>
+            <a:fld id="{4C0DE7E3-6817-D34F-9F2D-16E920BB51A9}" type="slidenum">
+              <a:rPr lang="en-CH" smtClean="0"/>
+              <a:t>7</a:t>
+            </a:fld>
+            <a:endParaRPr lang="en-CH"/>
+          </a:p>
+        </p:txBody>
+      </p:sp>
+    </p:spTree>
+    <p:extLst>
+      <p:ext uri="{BB962C8B-B14F-4D97-AF65-F5344CB8AC3E}">
+        <p14:creationId xmlns:p14="http://schemas.microsoft.com/office/powerpoint/2010/main" val="688627969"/>
+      </p:ext>
+    </p:extLst>
+  </p:cSld>
+  <p:clrMapOvr>
+    <a:masterClrMapping/>
+  </p:clrMapOvr>
+</p:notes>
+</file>
+
+<file path=ppt/notesSlides/notesSlide6.xml><?xml version="1.0" encoding="utf-8"?>
+<p:notes xmlns:a="http://schemas.openxmlformats.org/drawingml/2006/main" xmlns:r="http://schemas.openxmlformats.org/officeDocument/2006/relationships" xmlns:p="http://schemas.openxmlformats.org/presentationml/2006/main">
+  <p:cSld>
+    <p:spTree>
+      <p:nvGrpSpPr>
+        <p:cNvPr id="1" name=""/>
+        <p:cNvGrpSpPr/>
+        <p:nvPr/>
+      </p:nvGrpSpPr>
+      <p:grpSpPr>
+        <a:xfrm>
+          <a:off x="0" y="0"/>
+          <a:ext cx="0" cy="0"/>
+          <a:chOff x="0" y="0"/>
+          <a:chExt cx="0" cy="0"/>
+        </a:xfrm>
+      </p:grpSpPr>
+      <p:sp>
+        <p:nvSpPr>
+          <p:cNvPr id="2" name="Slide Image Placeholder 1"/>
+          <p:cNvSpPr>
+            <a:spLocks noGrp="1" noRot="1" noChangeAspect="1"/>
+          </p:cNvSpPr>
+          <p:nvPr>
+            <p:ph type="sldImg"/>
+          </p:nvPr>
+        </p:nvSpPr>
+        <p:spPr/>
+      </p:sp>
+      <p:sp>
+        <p:nvSpPr>
+          <p:cNvPr id="3" name="Notes Placeholder 2"/>
+          <p:cNvSpPr>
+            <a:spLocks noGrp="1"/>
+          </p:cNvSpPr>
+          <p:nvPr>
+            <p:ph type="body" idx="1"/>
+          </p:nvPr>
+        </p:nvSpPr>
+        <p:spPr/>
+        <p:txBody>
+          <a:bodyPr/>
+          <a:lstStyle/>
+          <a:p>
             <a:endParaRPr lang="de-CH" dirty="0"/>
           </a:p>
         </p:txBody>
@@ -1223,7 +1391,7 @@
 </p:notes>
 </file>
 
-<file path=ppt/notesSlides/notesSlide5.xml><?xml version="1.0" encoding="utf-8"?>
+<file path=ppt/notesSlides/notesSlide7.xml><?xml version="1.0" encoding="utf-8"?>
 <p:notes xmlns:a="http://schemas.openxmlformats.org/drawingml/2006/main" xmlns:r="http://schemas.openxmlformats.org/officeDocument/2006/relationships" xmlns:p="http://schemas.openxmlformats.org/presentationml/2006/main">
   <p:cSld>
     <p:spTree>
@@ -1331,7 +1499,7 @@
 </p:notes>
 </file>
 
-<file path=ppt/notesSlides/notesSlide6.xml><?xml version="1.0" encoding="utf-8"?>
+<file path=ppt/notesSlides/notesSlide8.xml><?xml version="1.0" encoding="utf-8"?>
 <p:notes xmlns:a="http://schemas.openxmlformats.org/drawingml/2006/main" xmlns:r="http://schemas.openxmlformats.org/officeDocument/2006/relationships" xmlns:p="http://schemas.openxmlformats.org/presentationml/2006/main">
   <p:cSld>
     <p:spTree>
@@ -1460,7 +1628,7 @@
 </p:notes>
 </file>
 
-<file path=ppt/notesSlides/notesSlide7.xml><?xml version="1.0" encoding="utf-8"?>
+<file path=ppt/notesSlides/notesSlide9.xml><?xml version="1.0" encoding="utf-8"?>
 <p:notes xmlns:a="http://schemas.openxmlformats.org/drawingml/2006/main" xmlns:r="http://schemas.openxmlformats.org/officeDocument/2006/relationships" xmlns:p="http://schemas.openxmlformats.org/presentationml/2006/main">
   <p:cSld>
     <p:spTree>
@@ -1723,7 +1891,7 @@
           <a:p>
             <a:fld id="{7E003D89-8BCB-CD45-BFFB-53322C8FC40E}" type="datetime1">
               <a:rPr lang="de-CH" smtClean="0"/>
-              <a:t>12.03.26</a:t>
+              <a:t>14.03.26</a:t>
             </a:fld>
             <a:endParaRPr lang="en-US"/>
           </a:p>
@@ -1872,7 +2040,7 @@
           <a:p>
             <a:fld id="{79121205-D078-FD46-AF85-0EF064AD968E}" type="datetime1">
               <a:rPr lang="de-CH" smtClean="0"/>
-              <a:t>12.03.26</a:t>
+              <a:t>14.03.26</a:t>
             </a:fld>
             <a:endParaRPr lang="en-US"/>
           </a:p>
@@ -2031,7 +2199,7 @@
           <a:p>
             <a:fld id="{CD8CCE81-C62E-2040-8EF1-B2DD76AF35C8}" type="datetime1">
               <a:rPr lang="de-CH" smtClean="0"/>
-              <a:t>12.03.26</a:t>
+              <a:t>14.03.26</a:t>
             </a:fld>
             <a:endParaRPr lang="en-US" dirty="0"/>
           </a:p>
@@ -2292,7 +2460,7 @@
           <a:p>
             <a:fld id="{79121205-D078-FD46-AF85-0EF064AD968E}" type="datetime1">
               <a:rPr lang="de-CH" smtClean="0"/>
-              <a:t>12.03.26</a:t>
+              <a:t>14.03.26</a:t>
             </a:fld>
             <a:endParaRPr lang="en-US"/>
           </a:p>
@@ -2457,7 +2625,7 @@
           <a:p>
             <a:fld id="{B79D91F7-C961-8C44-9299-BF84FF39514E}" type="datetime1">
               <a:rPr lang="de-CH" smtClean="0"/>
-              <a:t>12.03.26</a:t>
+              <a:t>14.03.26</a:t>
             </a:fld>
             <a:endParaRPr lang="en-US"/>
           </a:p>
@@ -2683,7 +2851,7 @@
           <a:p>
             <a:fld id="{FEC2240F-8AA3-2746-9A51-9D1A136F1E49}" type="datetime1">
               <a:rPr lang="de-CH" smtClean="0"/>
-              <a:t>12.03.26</a:t>
+              <a:t>14.03.26</a:t>
             </a:fld>
             <a:endParaRPr lang="en-US"/>
           </a:p>
@@ -2949,7 +3117,7 @@
           <a:p>
             <a:fld id="{03314D2E-D8E2-384B-82FD-655D508953A3}" type="datetime1">
               <a:rPr lang="de-CH" smtClean="0"/>
-              <a:t>12.03.26</a:t>
+              <a:t>14.03.26</a:t>
             </a:fld>
             <a:endParaRPr lang="en-US"/>
           </a:p>
@@ -3215,7 +3383,7 @@
           <a:p>
             <a:fld id="{EDA34BA8-55CE-D34A-9C2D-BEEE7446B5FC}" type="datetime1">
               <a:rPr lang="de-CH" smtClean="0"/>
-              <a:t>12.03.26</a:t>
+              <a:t>14.03.26</a:t>
             </a:fld>
             <a:endParaRPr lang="en-US"/>
           </a:p>
@@ -3313,7 +3481,7 @@
           <a:p>
             <a:fld id="{C469DC1D-08EC-344C-AFC6-70566B114C19}" type="datetime1">
               <a:rPr lang="de-CH" smtClean="0"/>
-              <a:t>12.03.26</a:t>
+              <a:t>14.03.26</a:t>
             </a:fld>
             <a:endParaRPr lang="en-US"/>
           </a:p>
@@ -3389,7 +3557,7 @@
           <a:p>
             <a:fld id="{B90EF599-0014-1B46-9369-317248A83AAA}" type="datetime1">
               <a:rPr lang="de-CH" smtClean="0"/>
-              <a:t>12.03.26</a:t>
+              <a:t>14.03.26</a:t>
             </a:fld>
             <a:endParaRPr lang="en-US"/>
           </a:p>
@@ -3645,7 +3813,7 @@
           <a:p>
             <a:fld id="{B21C5E05-3C90-7247-87A0-D89349E8E13C}" type="datetime1">
               <a:rPr lang="de-CH" smtClean="0"/>
-              <a:t>12.03.26</a:t>
+              <a:t>14.03.26</a:t>
             </a:fld>
             <a:endParaRPr lang="en-US"/>
           </a:p>
@@ -3878,7 +4046,7 @@
           <a:p>
             <a:fld id="{AD65A632-B168-4E45-8147-A4CCCC7F8728}" type="datetime1">
               <a:rPr lang="de-CH" smtClean="0"/>
-              <a:t>12.03.26</a:t>
+              <a:t>14.03.26</a:t>
             </a:fld>
             <a:endParaRPr lang="en-US"/>
           </a:p>
@@ -4070,7 +4238,7 @@
           <a:p>
             <a:fld id="{7291580A-F933-684E-A19D-31DC6358EE9E}" type="datetime1">
               <a:rPr lang="de-CH" smtClean="0"/>
-              <a:t>12.03.26</a:t>
+              <a:t>14.03.26</a:t>
             </a:fld>
             <a:endParaRPr lang="en-US"/>
           </a:p>
@@ -4817,10 +4985,10 @@
           <a:bodyPr/>
           <a:lstStyle/>
           <a:p>
-            <a:fld id="{72B55B63-FDB8-D940-A236-AF8A5F46C494}" type="datetime1">
-              <a:rPr lang="de-CH" smtClean="0"/>
-              <a:t>12.03.26</a:t>
-            </a:fld>
+            <a:r>
+              <a:rPr lang="de-CH" dirty="0"/>
+              <a:t>18.03.2026</a:t>
+            </a:r>
             <a:endParaRPr lang="en-US" dirty="0"/>
           </a:p>
         </p:txBody>
@@ -5621,35 +5789,6 @@
       </p:sp>
       <p:sp>
         <p:nvSpPr>
-          <p:cNvPr id="3" name="Date Placeholder 2">
-            <a:extLst>
-              <a:ext uri="{FF2B5EF4-FFF2-40B4-BE49-F238E27FC236}">
-                <a16:creationId xmlns:a16="http://schemas.microsoft.com/office/drawing/2014/main" id="{BE93191A-9F49-77A4-A044-4EF660116C41}"/>
-              </a:ext>
-            </a:extLst>
-          </p:cNvPr>
-          <p:cNvSpPr>
-            <a:spLocks noGrp="1"/>
-          </p:cNvSpPr>
-          <p:nvPr>
-            <p:ph type="dt" sz="half" idx="10"/>
-          </p:nvPr>
-        </p:nvSpPr>
-        <p:spPr/>
-        <p:txBody>
-          <a:bodyPr/>
-          <a:lstStyle/>
-          <a:p>
-            <a:fld id="{F9F3D982-4073-1C4A-9ED7-B56D2EA5D830}" type="datetime1">
-              <a:rPr lang="de-CH" smtClean="0"/>
-              <a:t>12.03.26</a:t>
-            </a:fld>
-            <a:endParaRPr lang="en-US"/>
-          </a:p>
-        </p:txBody>
-      </p:sp>
-      <p:sp>
-        <p:nvSpPr>
           <p:cNvPr id="4" name="Slide Number Placeholder 3">
             <a:extLst>
               <a:ext uri="{FF2B5EF4-FFF2-40B4-BE49-F238E27FC236}">
@@ -5896,39 +6035,42 @@
           <a:p>
             <a:pPr algn="l"/>
             <a:r>
-              <a:rPr lang="en-US" sz="2400" b="1"/>
+              <a:rPr lang="en-US" sz="2400" b="1" dirty="0"/>
               <a:t>Semantic Metadata Annotation</a:t>
             </a:r>
             <a:br>
-              <a:rPr lang="en-GB" sz="2700"/>
+              <a:rPr lang="en-GB" sz="2700" dirty="0"/>
             </a:br>
             <a:r>
-              <a:rPr lang="de-CH" sz="2000">
+              <a:rPr lang="de-CH" sz="2000" dirty="0" err="1">
                 <a:solidFill>
                   <a:schemeClr val="bg2">
                     <a:lumMod val="75000"/>
                   </a:schemeClr>
                 </a:solidFill>
               </a:rPr>
-              <a:t>Document </a:t>
-            </a:r>
-            <a:r>
-              <a:rPr lang="en-US" sz="2000">
+              <a:t>Document</a:t>
+            </a:r>
+            <a:r>
+              <a:rPr lang="de-CH" sz="2000" dirty="0">
                 <a:solidFill>
                   <a:schemeClr val="bg2">
                     <a:lumMod val="75000"/>
                   </a:schemeClr>
                 </a:solidFill>
               </a:rPr>
+              <a:t> </a:t>
+            </a:r>
+            <a:r>
+              <a:rPr lang="en-US" sz="2000" dirty="0">
+                <a:solidFill>
+                  <a:schemeClr val="bg2">
+                    <a:lumMod val="75000"/>
+                  </a:schemeClr>
+                </a:solidFill>
+              </a:rPr>
               <a:t>implementation and operational experience</a:t>
             </a:r>
-            <a:endParaRPr lang="en-US" sz="2000" dirty="0">
-              <a:solidFill>
-                <a:schemeClr val="bg2">
-                  <a:lumMod val="75000"/>
-                </a:schemeClr>
-              </a:solidFill>
-            </a:endParaRPr>
           </a:p>
         </p:txBody>
       </p:sp>
@@ -5949,7 +6091,7 @@
         <p:spPr>
           <a:xfrm>
             <a:off x="576000" y="1440000"/>
-            <a:ext cx="4933652" cy="3503212"/>
+            <a:ext cx="8110800" cy="2207440"/>
           </a:xfrm>
           <a:prstGeom prst="rect">
             <a:avLst/>
@@ -6097,44 +6239,64 @@
             </a:lvl9pPr>
           </a:lstStyle>
           <a:p>
-            <a:pPr>
+            <a:pPr marL="0" indent="0">
               <a:spcBef>
                 <a:spcPts val="225"/>
               </a:spcBef>
               <a:spcAft>
                 <a:spcPts val="225"/>
               </a:spcAft>
+              <a:buNone/>
             </a:pPr>
+            <a:r>
+              <a:rPr lang="de-CH" sz="1600" b="1" dirty="0" err="1"/>
+              <a:t>Snippet</a:t>
+            </a:r>
+            <a:r>
+              <a:rPr lang="de-CH" sz="1600" b="1" dirty="0"/>
+              <a:t> </a:t>
+            </a:r>
+            <a:r>
+              <a:rPr lang="de-CH" sz="1600" b="1" dirty="0" err="1"/>
+              <a:t>of</a:t>
+            </a:r>
+            <a:r>
+              <a:rPr lang="de-CH" sz="1600" b="1" dirty="0"/>
+              <a:t> </a:t>
+            </a:r>
+            <a:r>
+              <a:rPr lang="de-CH" sz="1600" b="1" dirty="0" err="1"/>
+              <a:t>message</a:t>
+            </a:r>
+            <a:r>
+              <a:rPr lang="de-CH" sz="1600" b="1" dirty="0"/>
+              <a:t> </a:t>
+            </a:r>
+            <a:r>
+              <a:rPr lang="de-CH" sz="1600" b="1" dirty="0" err="1"/>
+              <a:t>example</a:t>
+            </a:r>
+            <a:r>
+              <a:rPr lang="de-CH" sz="1600" b="1" dirty="0"/>
+              <a:t> </a:t>
+            </a:r>
+            <a:r>
+              <a:rPr lang="de-CH" sz="1600" b="1" dirty="0" err="1"/>
+              <a:t>from</a:t>
+            </a:r>
+            <a:r>
+              <a:rPr lang="de-CH" sz="1600" b="1" dirty="0"/>
+              <a:t> </a:t>
+            </a:r>
+            <a:r>
+              <a:rPr lang="de-CH" sz="1600" b="1" dirty="0" err="1"/>
+              <a:t>Cosmos</a:t>
+            </a:r>
+            <a:r>
+              <a:rPr lang="de-CH" sz="1600" b="1" dirty="0"/>
+              <a:t> Bright Lights Implementation</a:t>
+            </a:r>
             <a:endParaRPr lang="en-US" sz="1600" dirty="0"/>
-          </a:p>
-        </p:txBody>
-      </p:sp>
-      <p:sp>
-        <p:nvSpPr>
-          <p:cNvPr id="3" name="Date Placeholder 2">
-            <a:extLst>
-              <a:ext uri="{FF2B5EF4-FFF2-40B4-BE49-F238E27FC236}">
-                <a16:creationId xmlns:a16="http://schemas.microsoft.com/office/drawing/2014/main" id="{BB12B1B7-9471-301F-27F2-4FEB27401FA4}"/>
-              </a:ext>
-            </a:extLst>
-          </p:cNvPr>
-          <p:cNvSpPr>
-            <a:spLocks noGrp="1"/>
-          </p:cNvSpPr>
-          <p:nvPr>
-            <p:ph type="dt" sz="half" idx="10"/>
-          </p:nvPr>
-        </p:nvSpPr>
-        <p:spPr/>
-        <p:txBody>
-          <a:bodyPr/>
-          <a:lstStyle/>
-          <a:p>
-            <a:fld id="{C3D18FEC-DBD4-214C-B3C5-65378705016C}" type="datetime1">
-              <a:rPr lang="de-CH" smtClean="0"/>
-              <a:t>12.03.26</a:t>
-            </a:fld>
-            <a:endParaRPr lang="en-US"/>
           </a:p>
         </p:txBody>
       </p:sp>
@@ -6872,54 +7034,6 @@
             <a:pPr marL="0" indent="0">
               <a:buNone/>
             </a:pPr>
-            <a:r>
-              <a:rPr lang="de-CH" sz="1400" b="1" dirty="0" err="1"/>
-              <a:t>Snippet</a:t>
-            </a:r>
-            <a:r>
-              <a:rPr lang="de-CH" sz="1400" b="1" dirty="0"/>
-              <a:t> </a:t>
-            </a:r>
-            <a:r>
-              <a:rPr lang="de-CH" sz="1400" b="1" dirty="0" err="1"/>
-              <a:t>of</a:t>
-            </a:r>
-            <a:r>
-              <a:rPr lang="de-CH" sz="1400" b="1" dirty="0"/>
-              <a:t> </a:t>
-            </a:r>
-            <a:r>
-              <a:rPr lang="de-CH" sz="1400" b="1" dirty="0" err="1"/>
-              <a:t>message</a:t>
-            </a:r>
-            <a:r>
-              <a:rPr lang="de-CH" sz="1400" b="1" dirty="0"/>
-              <a:t> </a:t>
-            </a:r>
-            <a:r>
-              <a:rPr lang="de-CH" sz="1400" b="1" dirty="0" err="1"/>
-              <a:t>example</a:t>
-            </a:r>
-            <a:r>
-              <a:rPr lang="de-CH" sz="1400" b="1" dirty="0"/>
-              <a:t> </a:t>
-            </a:r>
-            <a:r>
-              <a:rPr lang="de-CH" sz="1400" b="1" dirty="0" err="1"/>
-              <a:t>from</a:t>
-            </a:r>
-            <a:r>
-              <a:rPr lang="de-CH" sz="1400" b="1" dirty="0"/>
-              <a:t> </a:t>
-            </a:r>
-            <a:r>
-              <a:rPr lang="de-CH" sz="1400" b="1" dirty="0" err="1"/>
-              <a:t>Cosmos</a:t>
-            </a:r>
-            <a:r>
-              <a:rPr lang="de-CH" sz="1400" b="1" dirty="0"/>
-              <a:t> Bright Lights Implementation</a:t>
-            </a:r>
             <a:br>
               <a:rPr lang="de-CH" sz="1000" b="1" dirty="0"/>
             </a:br>
@@ -7498,23 +7612,7 @@
           <a:p>
             <a:r>
               <a:rPr lang="en-US" dirty="0"/>
-              <a:t>draft-</a:t>
-            </a:r>
-            <a:r>
-              <a:rPr lang="en-US" dirty="0" err="1"/>
-              <a:t>ietf</a:t>
-            </a:r>
-            <a:r>
-              <a:rPr lang="en-US" dirty="0"/>
-              <a:t>-</a:t>
-            </a:r>
-            <a:r>
-              <a:rPr lang="en-US" dirty="0" err="1"/>
-              <a:t>nmop</a:t>
-            </a:r>
-            <a:r>
-              <a:rPr lang="en-US" dirty="0"/>
-              <a:t>-network-anomaly-lifecycle</a:t>
+              <a:t>draft-ietf-nmop-network-anomaly-lifecycle-05</a:t>
             </a:r>
             <a:br>
               <a:rPr lang="en-CH" dirty="0"/>
@@ -7548,35 +7646,6 @@
               <a:rPr lang="en-US" b="1" dirty="0"/>
               <a:t>Network Anomaly Lifecycle</a:t>
             </a:r>
-          </a:p>
-        </p:txBody>
-      </p:sp>
-      <p:sp>
-        <p:nvSpPr>
-          <p:cNvPr id="4" name="Date Placeholder 3">
-            <a:extLst>
-              <a:ext uri="{FF2B5EF4-FFF2-40B4-BE49-F238E27FC236}">
-                <a16:creationId xmlns:a16="http://schemas.microsoft.com/office/drawing/2014/main" id="{2E463632-3F9F-0DF2-ACA4-AD1A8C5E14E5}"/>
-              </a:ext>
-            </a:extLst>
-          </p:cNvPr>
-          <p:cNvSpPr>
-            <a:spLocks noGrp="1"/>
-          </p:cNvSpPr>
-          <p:nvPr>
-            <p:ph type="dt" sz="half" idx="10"/>
-          </p:nvPr>
-        </p:nvSpPr>
-        <p:spPr/>
-        <p:txBody>
-          <a:bodyPr/>
-          <a:lstStyle/>
-          <a:p>
-            <a:fld id="{FEC2240F-8AA3-2746-9A51-9D1A136F1E49}" type="datetime1">
-              <a:rPr lang="de-CH" smtClean="0"/>
-              <a:t>12.03.26</a:t>
-            </a:fld>
-            <a:endParaRPr lang="en-US"/>
           </a:p>
         </p:txBody>
       </p:sp>
@@ -7728,7 +7797,7 @@
         </p:nvSpPr>
         <p:spPr>
           <a:xfrm>
-            <a:off x="576000" y="2160000"/>
+            <a:off x="720000" y="1800000"/>
             <a:ext cx="4544034" cy="3503212"/>
           </a:xfrm>
         </p:spPr>
@@ -7748,79 +7817,149 @@
               <a:buNone/>
             </a:pPr>
             <a:r>
+              <a:rPr lang="en-GB" sz="1600" b="1" dirty="0"/>
+              <a:t>Motivation:</a:t>
+            </a:r>
+          </a:p>
+          <a:p>
+            <a:pPr marL="0" indent="0">
+              <a:spcBef>
+                <a:spcPts val="225"/>
+              </a:spcBef>
+              <a:spcAft>
+                <a:spcPts val="225"/>
+              </a:spcAft>
+              <a:buNone/>
+            </a:pPr>
+            <a:r>
+              <a:rPr lang="en-GB" sz="1600" dirty="0">
+                <a:solidFill>
+                  <a:schemeClr val="accent2"/>
+                </a:solidFill>
+              </a:rPr>
+              <a:t>Bridge the gap </a:t>
+            </a:r>
+            <a:r>
               <a:rPr lang="en-GB" sz="1600" dirty="0"/>
-              <a:t>To bridge the gap between </a:t>
-            </a:r>
+              <a:t>between automated network anomaly detection and actionable operational tasks</a:t>
+            </a:r>
+          </a:p>
+          <a:p>
+            <a:pPr marL="0" indent="0">
+              <a:spcBef>
+                <a:spcPts val="225"/>
+              </a:spcBef>
+              <a:spcAft>
+                <a:spcPts val="225"/>
+              </a:spcAft>
+              <a:buNone/>
+            </a:pPr>
+            <a:endParaRPr lang="en-GB" sz="1600" dirty="0"/>
+          </a:p>
+          <a:p>
+            <a:pPr marL="0" indent="0">
+              <a:spcBef>
+                <a:spcPts val="225"/>
+              </a:spcBef>
+              <a:spcAft>
+                <a:spcPts val="225"/>
+              </a:spcAft>
+              <a:buNone/>
+            </a:pPr>
             <a:r>
               <a:rPr lang="en-GB" sz="1600" b="1" dirty="0"/>
-              <a:t>automated network anomaly detection</a:t>
-            </a:r>
+              <a:t>Approach:</a:t>
+            </a:r>
+          </a:p>
+          <a:p>
+            <a:pPr marL="0" indent="0">
+              <a:spcBef>
+                <a:spcPts val="225"/>
+              </a:spcBef>
+              <a:spcAft>
+                <a:spcPts val="225"/>
+              </a:spcAft>
+              <a:buNone/>
+            </a:pPr>
             <a:r>
               <a:rPr lang="en-GB" sz="1600" dirty="0"/>
-              <a:t> and </a:t>
-            </a:r>
+              <a:t>Define a </a:t>
+            </a:r>
+            <a:r>
+              <a:rPr lang="en-GB" sz="1600" dirty="0">
+                <a:solidFill>
+                  <a:schemeClr val="accent2"/>
+                </a:solidFill>
+              </a:rPr>
+              <a:t>standardized, iterative lifecycle </a:t>
+            </a:r>
+            <a:r>
+              <a:rPr lang="en-GB" sz="1600" dirty="0"/>
+              <a:t>for Network anomaly</a:t>
+            </a:r>
+          </a:p>
+          <a:p>
+            <a:pPr marL="0" indent="0">
+              <a:spcBef>
+                <a:spcPts val="225"/>
+              </a:spcBef>
+              <a:spcAft>
+                <a:spcPts val="225"/>
+              </a:spcAft>
+              <a:buNone/>
+            </a:pPr>
+            <a:endParaRPr lang="en-GB" sz="1600" dirty="0"/>
+          </a:p>
+          <a:p>
+            <a:pPr marL="0" indent="0">
+              <a:spcBef>
+                <a:spcPts val="225"/>
+              </a:spcBef>
+              <a:spcAft>
+                <a:spcPts val="225"/>
+              </a:spcAft>
+              <a:buNone/>
+            </a:pPr>
             <a:r>
               <a:rPr lang="en-GB" sz="1600" b="1" dirty="0"/>
-              <a:t>actionable operational tasks</a:t>
+              <a:t>Outcome:</a:t>
+            </a:r>
+          </a:p>
+          <a:p>
+            <a:pPr marL="0" indent="0">
+              <a:spcBef>
+                <a:spcPts val="225"/>
+              </a:spcBef>
+              <a:spcAft>
+                <a:spcPts val="225"/>
+              </a:spcAft>
+              <a:buNone/>
+            </a:pPr>
+            <a:r>
+              <a:rPr lang="en-GB" sz="1600" dirty="0">
+                <a:solidFill>
+                  <a:schemeClr val="accent2"/>
+                </a:solidFill>
+              </a:rPr>
+              <a:t>Continuously Improve</a:t>
             </a:r>
             <a:r>
               <a:rPr lang="en-GB" sz="1600" dirty="0"/>
-              <a:t>, this draft defines a standardized, </a:t>
-            </a:r>
-            <a:r>
-              <a:rPr lang="en-GB" sz="1600" b="1" dirty="0"/>
-              <a:t>iterative lifecycle</a:t>
-            </a:r>
-            <a:r>
-              <a:rPr lang="en-GB" sz="1600" dirty="0"/>
-              <a:t> designed to improve the </a:t>
-            </a:r>
-            <a:r>
-              <a:rPr lang="en-GB" sz="1600" b="1" dirty="0"/>
-              <a:t>correctness</a:t>
-            </a:r>
-            <a:r>
-              <a:rPr lang="en-GB" sz="1600" dirty="0"/>
-              <a:t> of anomaly detection system through </a:t>
-            </a:r>
-            <a:r>
-              <a:rPr lang="en-GB" sz="1600" b="1" dirty="0"/>
-              <a:t>human-in-the-loop feedback</a:t>
-            </a:r>
-            <a:r>
-              <a:rPr lang="en-GB" sz="1600" dirty="0"/>
-              <a:t>.</a:t>
-            </a:r>
-            <a:endParaRPr lang="en-US" sz="1600" dirty="0"/>
-          </a:p>
-        </p:txBody>
-      </p:sp>
-      <p:sp>
-        <p:nvSpPr>
-          <p:cNvPr id="4" name="Date Placeholder 3">
-            <a:extLst>
-              <a:ext uri="{FF2B5EF4-FFF2-40B4-BE49-F238E27FC236}">
-                <a16:creationId xmlns:a16="http://schemas.microsoft.com/office/drawing/2014/main" id="{D267A8B2-8110-8A83-A0EA-AFAC81BAC75E}"/>
-              </a:ext>
-            </a:extLst>
-          </p:cNvPr>
-          <p:cNvSpPr>
-            <a:spLocks noGrp="1"/>
-          </p:cNvSpPr>
-          <p:nvPr>
-            <p:ph type="dt" sz="half" idx="10"/>
-          </p:nvPr>
-        </p:nvSpPr>
-        <p:spPr/>
-        <p:txBody>
-          <a:bodyPr/>
-          <a:lstStyle/>
-          <a:p>
-            <a:fld id="{DACD52A1-C0F7-0F48-BE0F-BBA5E31D6A37}" type="datetime1">
-              <a:rPr lang="de-CH" smtClean="0"/>
-              <a:t>12.03.26</a:t>
-            </a:fld>
-            <a:endParaRPr lang="en-US"/>
+              <a:t> the correctness of anomaly detection through</a:t>
+            </a:r>
+            <a:r>
+              <a:rPr lang="en-GB" sz="1600" dirty="0">
+                <a:solidFill>
+                  <a:schemeClr val="accent2"/>
+                </a:solidFill>
+              </a:rPr>
+              <a:t> human‑in‑the‑loop feedback</a:t>
+            </a:r>
+            <a:endParaRPr lang="en-US" sz="1600" dirty="0">
+              <a:solidFill>
+                <a:schemeClr val="accent2"/>
+              </a:solidFill>
+            </a:endParaRPr>
           </a:p>
         </p:txBody>
       </p:sp>
@@ -8442,35 +8581,6 @@
       </p:sp>
       <p:sp>
         <p:nvSpPr>
-          <p:cNvPr id="4" name="Date Placeholder 3">
-            <a:extLst>
-              <a:ext uri="{FF2B5EF4-FFF2-40B4-BE49-F238E27FC236}">
-                <a16:creationId xmlns:a16="http://schemas.microsoft.com/office/drawing/2014/main" id="{D23EFB7D-7A6B-4DAE-2C0E-AE760EA1E479}"/>
-              </a:ext>
-            </a:extLst>
-          </p:cNvPr>
-          <p:cNvSpPr>
-            <a:spLocks noGrp="1"/>
-          </p:cNvSpPr>
-          <p:nvPr>
-            <p:ph type="dt" sz="half" idx="10"/>
-          </p:nvPr>
-        </p:nvSpPr>
-        <p:spPr/>
-        <p:txBody>
-          <a:bodyPr/>
-          <a:lstStyle/>
-          <a:p>
-            <a:fld id="{6CCDDB14-30A2-2E47-B57D-285D0E17FE10}" type="datetime1">
-              <a:rPr lang="de-CH" smtClean="0"/>
-              <a:t>12.03.26</a:t>
-            </a:fld>
-            <a:endParaRPr lang="en-US"/>
-          </a:p>
-        </p:txBody>
-      </p:sp>
-      <p:sp>
-        <p:nvSpPr>
           <p:cNvPr id="5" name="Slide Number Placeholder 4">
             <a:extLst>
               <a:ext uri="{FF2B5EF4-FFF2-40B4-BE49-F238E27FC236}">
@@ -9090,7 +9200,27 @@
             </a:pPr>
             <a:r>
               <a:rPr lang="en-IE" sz="1600" dirty="0"/>
-              <a:t>Requesting working group feedback on the editorial changes.</a:t>
+              <a:t>Request YANG doctors review for </a:t>
+            </a:r>
+            <a:r>
+              <a:rPr lang="en-US" sz="1600" dirty="0">
+                <a:hlinkClick r:id="rId3"/>
+              </a:rPr>
+              <a:t>draft-ietf-nmop-network-anomaly-semantics-05</a:t>
+            </a:r>
+            <a:r>
+              <a:rPr lang="en-US" sz="1600" dirty="0"/>
+              <a:t> and </a:t>
+            </a:r>
+            <a:r>
+              <a:rPr lang="en-US" sz="1600" dirty="0">
+                <a:hlinkClick r:id="rId4"/>
+              </a:rPr>
+              <a:t>draft-ietf-nmop-network-anomaly-lifecycle-05</a:t>
+            </a:r>
+            <a:r>
+              <a:rPr lang="en-US" sz="1600" dirty="0"/>
+              <a:t>.</a:t>
             </a:r>
           </a:p>
           <a:p>
@@ -9105,28 +9235,50 @@
               <a:buChar char="•"/>
             </a:pPr>
             <a:r>
-              <a:rPr lang="en-IE" sz="1600" dirty="0"/>
-              <a:t>Request YANG doctors review for </a:t>
-            </a:r>
-            <a:r>
-              <a:rPr lang="en-US" sz="1600" dirty="0">
-                <a:hlinkClick r:id="rId3"/>
-              </a:rPr>
-              <a:t>draft-ietf-nmop-network-anomaly-semantics-05</a:t>
-            </a:r>
-            <a:r>
               <a:rPr lang="en-US" sz="1600" dirty="0"/>
-              <a:t> and </a:t>
-            </a:r>
-            <a:r>
-              <a:rPr lang="en-US" sz="1600" dirty="0">
-                <a:hlinkClick r:id="rId4"/>
-              </a:rPr>
-              <a:t>draft-ietf-nmop-network-anomaly-lifecycle-05</a:t>
-            </a:r>
+              <a:t>Implement semantic metadata in Cosmos Bright Lights to replace placeholder values for newly introduced fields, including </a:t>
+            </a:r>
+          </a:p>
+          <a:p>
+            <a:pPr marL="501750" lvl="1" indent="-285750">
+              <a:spcBef>
+                <a:spcPts val="300"/>
+              </a:spcBef>
+              <a:spcAft>
+                <a:spcPts val="300"/>
+              </a:spcAft>
+            </a:pPr>
             <a:r>
               <a:rPr lang="en-US" sz="1600" dirty="0"/>
-              <a:t>.</a:t>
+              <a:t>site‑ids</a:t>
+            </a:r>
+          </a:p>
+          <a:p>
+            <a:pPr marL="501750" lvl="1" indent="-285750">
+              <a:spcBef>
+                <a:spcPts val="300"/>
+              </a:spcBef>
+              <a:spcAft>
+                <a:spcPts val="300"/>
+              </a:spcAft>
+            </a:pPr>
+            <a:r>
+              <a:rPr lang="en-US" sz="1600" dirty="0"/>
+              <a:t>interface names</a:t>
+            </a:r>
+          </a:p>
+          <a:p>
+            <a:pPr marL="501750" lvl="1" indent="-285750">
+              <a:spcBef>
+                <a:spcPts val="300"/>
+              </a:spcBef>
+              <a:spcAft>
+                <a:spcPts val="300"/>
+              </a:spcAft>
+            </a:pPr>
+            <a:r>
+              <a:rPr lang="en-US" sz="1600" dirty="0"/>
+              <a:t>VRF names</a:t>
             </a:r>
           </a:p>
           <a:p>
@@ -9142,37 +9294,8 @@
             </a:pPr>
             <a:r>
               <a:rPr lang="en-US" sz="1600" dirty="0"/>
-              <a:t>Implement semantic metadata in Cosmos Bright Lights to replace placeholder values (null) for newly introduced fields, including site‑ids, interface names, and VRF names.</a:t>
-            </a:r>
-          </a:p>
-          <a:p>
-            <a:pPr marL="285750" indent="-285750">
-              <a:spcBef>
-                <a:spcPts val="300"/>
-              </a:spcBef>
-              <a:spcAft>
-                <a:spcPts val="300"/>
-              </a:spcAft>
-              <a:buFont typeface="Arial" panose="020B0604020202020204" pitchFamily="34" charset="0"/>
-              <a:buChar char="•"/>
-            </a:pPr>
-            <a:r>
-              <a:rPr lang="en-US" sz="1600" dirty="0"/>
-              <a:t>Extend the postmortem system requirements, accompanied by an implementation proof of concept</a:t>
-            </a:r>
-          </a:p>
-          <a:p>
-            <a:pPr marL="285750" indent="-285750">
-              <a:spcBef>
-                <a:spcPts val="300"/>
-              </a:spcBef>
-              <a:spcAft>
-                <a:spcPts val="300"/>
-              </a:spcAft>
-              <a:buFont typeface="Arial" panose="020B0604020202020204" pitchFamily="34" charset="0"/>
-              <a:buChar char="•"/>
-            </a:pPr>
-            <a:endParaRPr lang="en-US" sz="1600" dirty="0"/>
+              <a:t>Extend the postmortem system requirements, accompanied by an implementation PoC</a:t>
+            </a:r>
           </a:p>
           <a:p>
             <a:pPr>
@@ -9185,7 +9308,7 @@
             </a:pPr>
             <a:r>
               <a:rPr lang="en-IE" sz="1400" b="1" dirty="0"/>
-              <a:t>Remaining Issue</a:t>
+              <a:t>Remaining Issues</a:t>
             </a:r>
           </a:p>
           <a:p>
@@ -9565,7 +9688,19 @@
           <a:p>
             <a:r>
               <a:rPr lang="en-GB" sz="1600" dirty="0"/>
-              <a:t>To detect service interruptions before users do, network operations must use </a:t>
+              <a:t>To </a:t>
+            </a:r>
+            <a:r>
+              <a:rPr lang="en-GB" sz="1600" b="1" dirty="0">
+                <a:solidFill>
+                  <a:schemeClr val="accent4"/>
+                </a:solidFill>
+              </a:rPr>
+              <a:t>detect service interruptions</a:t>
+            </a:r>
+            <a:r>
+              <a:rPr lang="en-GB" sz="1600" dirty="0"/>
+              <a:t> before users do, network operations must use </a:t>
             </a:r>
             <a:r>
               <a:rPr lang="en-GB" sz="1600" b="1" dirty="0"/>
@@ -9599,28 +9734,105 @@
             </a:pPr>
             <a:r>
               <a:rPr lang="en-US" sz="1600" dirty="0">
-                <a:hlinkClick r:id="rId2"/>
+                <a:solidFill>
+                  <a:schemeClr val="accent4"/>
+                </a:solidFill>
+                <a:hlinkClick r:id="rId2">
+                  <a:extLst>
+                    <a:ext uri="{A12FA001-AC4F-418D-AE19-62706E023703}">
+                      <ahyp:hlinkClr xmlns:ahyp="http://schemas.microsoft.com/office/drawing/2018/hyperlinkcolor" val="tx"/>
+                    </a:ext>
+                  </a:extLst>
+                </a:hlinkClick>
               </a:rPr>
               <a:t>draft-ietf-nmop-network-anomaly-architecture</a:t>
             </a:r>
             <a:r>
               <a:rPr lang="en-US" sz="1600" dirty="0"/>
-              <a:t> describes the motivation, architecture and the relationship to other two documents.</a:t>
+              <a:t> describes the </a:t>
+            </a:r>
+            <a:r>
+              <a:rPr lang="en-US" sz="1600" b="1" dirty="0"/>
+              <a:t>motivation</a:t>
+            </a:r>
+            <a:r>
+              <a:rPr lang="en-US" sz="1600" dirty="0"/>
+              <a:t>, </a:t>
+            </a:r>
+            <a:r>
+              <a:rPr lang="en-US" sz="1600" b="1" dirty="0"/>
+              <a:t>architecture</a:t>
+            </a:r>
+            <a:r>
+              <a:rPr lang="en-US" sz="1600" dirty="0"/>
+              <a:t> and the </a:t>
+            </a:r>
+            <a:r>
+              <a:rPr lang="en-US" sz="1600" b="1" dirty="0"/>
+              <a:t>relationship</a:t>
+            </a:r>
+            <a:r>
+              <a:rPr lang="en-US" sz="1600" dirty="0"/>
+              <a:t> to other two documents.</a:t>
             </a:r>
             <a:endParaRPr lang="en-GB" sz="1600" dirty="0"/>
           </a:p>
           <a:p>
             <a:r>
               <a:rPr lang="en-GB" sz="1600" dirty="0"/>
-              <a:t>By automating the postmortem process and standardizing </a:t>
-            </a:r>
-            <a:r>
-              <a:rPr lang="en-GB" sz="1600" dirty="0" err="1"/>
+              <a:t>By </a:t>
+            </a:r>
+            <a:r>
+              <a:rPr lang="en-GB" sz="1600" b="1" dirty="0">
+                <a:solidFill>
+                  <a:schemeClr val="accent1"/>
+                </a:solidFill>
+              </a:rPr>
+              <a:t>standardizing </a:t>
+            </a:r>
+            <a:r>
+              <a:rPr lang="en-GB" sz="1600" b="1" dirty="0" err="1">
+                <a:solidFill>
+                  <a:schemeClr val="accent1"/>
+                </a:solidFill>
+              </a:rPr>
               <a:t>labeled</a:t>
             </a:r>
             <a:r>
+              <a:rPr lang="en-GB" sz="1600" b="1" dirty="0">
+                <a:solidFill>
+                  <a:schemeClr val="accent1"/>
+                </a:solidFill>
+              </a:rPr>
+              <a:t> incident data </a:t>
+            </a:r>
+            <a:r>
               <a:rPr lang="en-GB" sz="1600" dirty="0"/>
-              <a:t> incident data, operators can</a:t>
+              <a:t>and </a:t>
+            </a:r>
+            <a:r>
+              <a:rPr lang="en-GB" sz="1600" b="1" dirty="0">
+                <a:solidFill>
+                  <a:schemeClr val="accent6"/>
+                </a:solidFill>
+              </a:rPr>
+              <a:t>automating the </a:t>
+            </a:r>
+            <a:r>
+              <a:rPr lang="en-GB" sz="1600" b="1">
+                <a:solidFill>
+                  <a:schemeClr val="accent6"/>
+                </a:solidFill>
+              </a:rPr>
+              <a:t>postmortem process</a:t>
+            </a:r>
+            <a:r>
+              <a:rPr lang="en-GB" sz="1600" b="1"/>
+              <a:t>, </a:t>
+            </a:r>
+            <a:r>
+              <a:rPr lang="en-GB" sz="1600" dirty="0"/>
+              <a:t>operators can</a:t>
             </a:r>
             <a:r>
               <a:rPr lang="en-GB" sz="1600" b="1" dirty="0"/>
@@ -9646,13 +9858,38 @@
             </a:pPr>
             <a:r>
               <a:rPr lang="en-US" sz="1600" dirty="0">
-                <a:hlinkClick r:id="rId3"/>
+                <a:solidFill>
+                  <a:schemeClr val="accent1"/>
+                </a:solidFill>
+                <a:hlinkClick r:id="rId3">
+                  <a:extLst>
+                    <a:ext uri="{A12FA001-AC4F-418D-AE19-62706E023703}">
+                      <ahyp:hlinkClr xmlns:ahyp="http://schemas.microsoft.com/office/drawing/2018/hyperlinkcolor" val="tx"/>
+                    </a:ext>
+                  </a:extLst>
+                </a:hlinkClick>
               </a:rPr>
               <a:t>draft-ietf-nmop-network-anomaly-semantics</a:t>
             </a:r>
             <a:r>
               <a:rPr lang="en-US" sz="1600" dirty="0"/>
-              <a:t> defines Symptom semantics to enable standardized data exchange to validate results with network engineers and improve supervised and semi-supervised machine learning systems. </a:t>
+              <a:t> defines Symptom semantics to enable </a:t>
+            </a:r>
+            <a:r>
+              <a:rPr lang="en-US" sz="1600" b="1" dirty="0"/>
+              <a:t>standardized data exchange </a:t>
+            </a:r>
+            <a:r>
+              <a:rPr lang="en-US" sz="1600" dirty="0"/>
+              <a:t>to </a:t>
+            </a:r>
+            <a:r>
+              <a:rPr lang="en-US" sz="1600" b="1" dirty="0"/>
+              <a:t>validate results</a:t>
+            </a:r>
+            <a:r>
+              <a:rPr lang="en-US" sz="1600" dirty="0"/>
+              <a:t> with network engineers and improve supervised and semi-supervised machine learning systems. </a:t>
             </a:r>
           </a:p>
           <a:p>
@@ -9662,13 +9899,38 @@
             </a:pPr>
             <a:r>
               <a:rPr lang="en-US" sz="1600" dirty="0">
-                <a:hlinkClick r:id="rId4"/>
+                <a:solidFill>
+                  <a:schemeClr val="accent6"/>
+                </a:solidFill>
+                <a:hlinkClick r:id="rId4">
+                  <a:extLst>
+                    <a:ext uri="{A12FA001-AC4F-418D-AE19-62706E023703}">
+                      <ahyp:hlinkClr xmlns:ahyp="http://schemas.microsoft.com/office/drawing/2018/hyperlinkcolor" val="tx"/>
+                    </a:ext>
+                  </a:extLst>
+                </a:hlinkClick>
               </a:rPr>
               <a:t>draft-ietf-nmop-network-anomaly-lifecycle</a:t>
             </a:r>
             <a:r>
               <a:rPr lang="en-US" sz="1600" dirty="0"/>
-              <a:t> describes the lifecycle process, enabling network engineers to interact with the network anomaly detection system to refine the detection abilities over time. </a:t>
+              <a:t> describes the lifecycle process, enabling network engineers to </a:t>
+            </a:r>
+            <a:r>
+              <a:rPr lang="en-US" sz="1600" b="1" dirty="0"/>
+              <a:t>interact</a:t>
+            </a:r>
+            <a:r>
+              <a:rPr lang="en-US" sz="1600" dirty="0"/>
+              <a:t> with the network anomaly detection system to </a:t>
+            </a:r>
+            <a:r>
+              <a:rPr lang="en-US" sz="1600" b="1" dirty="0"/>
+              <a:t>refine the detection abilities</a:t>
+            </a:r>
+            <a:r>
+              <a:rPr lang="en-US" sz="1600" dirty="0"/>
+              <a:t> over time. </a:t>
             </a:r>
             <a:endParaRPr lang="en-GB" sz="1600" dirty="0"/>
           </a:p>
@@ -10334,24 +10596,8 @@
           <a:lstStyle/>
           <a:p>
             <a:r>
-              <a:rPr lang="en-US" dirty="0"/>
-              <a:t>draft-</a:t>
-            </a:r>
-            <a:r>
-              <a:rPr lang="en-US" dirty="0" err="1"/>
-              <a:t>ietf</a:t>
-            </a:r>
-            <a:r>
-              <a:rPr lang="en-US" dirty="0"/>
-              <a:t>-</a:t>
-            </a:r>
-            <a:r>
-              <a:rPr lang="en-US" dirty="0" err="1"/>
-              <a:t>nmop</a:t>
-            </a:r>
-            <a:r>
-              <a:rPr lang="en-US" dirty="0"/>
-              <a:t>-network-anomaly-architecture</a:t>
+              <a:rPr lang="en-US"/>
+              <a:t>draft-ietf-nmop-network-anomaly-architecture-07</a:t>
             </a:r>
             <a:br>
               <a:rPr lang="en-CH" dirty="0"/>
@@ -10386,35 +10632,6 @@
               <a:t>Network Anomaly Detection Architecture</a:t>
             </a:r>
             <a:endParaRPr lang="en-CH" dirty="0"/>
-          </a:p>
-        </p:txBody>
-      </p:sp>
-      <p:sp>
-        <p:nvSpPr>
-          <p:cNvPr id="4" name="Date Placeholder 3">
-            <a:extLst>
-              <a:ext uri="{FF2B5EF4-FFF2-40B4-BE49-F238E27FC236}">
-                <a16:creationId xmlns:a16="http://schemas.microsoft.com/office/drawing/2014/main" id="{72120A11-F19F-14C7-6A03-E0F90251AA46}"/>
-              </a:ext>
-            </a:extLst>
-          </p:cNvPr>
-          <p:cNvSpPr>
-            <a:spLocks noGrp="1"/>
-          </p:cNvSpPr>
-          <p:nvPr>
-            <p:ph type="dt" sz="half" idx="10"/>
-          </p:nvPr>
-        </p:nvSpPr>
-        <p:spPr/>
-        <p:txBody>
-          <a:bodyPr/>
-          <a:lstStyle/>
-          <a:p>
-            <a:fld id="{FEC2240F-8AA3-2746-9A51-9D1A136F1E49}" type="datetime1">
-              <a:rPr lang="de-CH" smtClean="0"/>
-              <a:t>12.03.26</a:t>
-            </a:fld>
-            <a:endParaRPr lang="en-US"/>
           </a:p>
         </p:txBody>
       </p:sp>
@@ -10539,8 +10756,8 @@
         </p:nvSpPr>
         <p:spPr>
           <a:xfrm>
-            <a:off x="576000" y="2160018"/>
-            <a:ext cx="3382389" cy="3255375"/>
+            <a:off x="720000" y="1800000"/>
+            <a:ext cx="3382389" cy="3997755"/>
           </a:xfrm>
         </p:spPr>
         <p:txBody>
@@ -10559,40 +10776,12 @@
               <a:buNone/>
             </a:pPr>
             <a:r>
-              <a:rPr lang="en-GB" sz="1600"/>
-              <a:t>As human-driven troubleshooting becomes less </a:t>
-            </a:r>
-            <a:r>
-              <a:rPr lang="en-GB" sz="1600" b="1"/>
-              <a:t>scalable</a:t>
-            </a:r>
-            <a:r>
-              <a:rPr lang="en-GB" sz="1600"/>
-              <a:t> due to its vast number of dependencies, this draft outlines a </a:t>
-            </a:r>
-            <a:r>
-              <a:rPr lang="en-GB" sz="1600" b="1"/>
-              <a:t>standardized</a:t>
-            </a:r>
-            <a:r>
-              <a:rPr lang="en-GB" sz="1600"/>
-              <a:t>, </a:t>
-            </a:r>
-            <a:r>
-              <a:rPr lang="en-GB" sz="1600" b="1"/>
-              <a:t>architecture-level framework</a:t>
-            </a:r>
-            <a:r>
-              <a:rPr lang="en-GB" sz="1600"/>
-              <a:t> designed to </a:t>
-            </a:r>
-            <a:r>
-              <a:rPr lang="en-GB" sz="1600" b="1"/>
-              <a:t>automate the detection of service disruptions</a:t>
-            </a:r>
-            <a:r>
               <a:rPr lang="en-GB" sz="1600" b="1" dirty="0"/>
-              <a:t>.</a:t>
+              <a:t>Motivation</a:t>
+            </a:r>
+            <a:r>
+              <a:rPr lang="en-GB" sz="1600" dirty="0"/>
+              <a:t>: </a:t>
             </a:r>
           </a:p>
           <a:p>
@@ -10605,7 +10794,135 @@
               </a:spcAft>
               <a:buNone/>
             </a:pPr>
-            <a:endParaRPr lang="en-US" sz="1600" dirty="0"/>
+            <a:r>
+              <a:rPr lang="en-GB" sz="1600" dirty="0"/>
+              <a:t>Human‑driven troubleshooting does not </a:t>
+            </a:r>
+            <a:r>
+              <a:rPr lang="en-GB" sz="1600" dirty="0">
+                <a:solidFill>
+                  <a:schemeClr val="accent2"/>
+                </a:solidFill>
+              </a:rPr>
+              <a:t>scale</a:t>
+            </a:r>
+            <a:r>
+              <a:rPr lang="en-GB" sz="1600" dirty="0"/>
+              <a:t> due to the growing number of dependencies</a:t>
+            </a:r>
+          </a:p>
+          <a:p>
+            <a:pPr marL="0" indent="0">
+              <a:spcBef>
+                <a:spcPts val="225"/>
+              </a:spcBef>
+              <a:spcAft>
+                <a:spcPts val="225"/>
+              </a:spcAft>
+              <a:buNone/>
+            </a:pPr>
+            <a:endParaRPr lang="en-GB" sz="1600" dirty="0"/>
+          </a:p>
+          <a:p>
+            <a:pPr marL="0" indent="0">
+              <a:spcBef>
+                <a:spcPts val="225"/>
+              </a:spcBef>
+              <a:spcAft>
+                <a:spcPts val="225"/>
+              </a:spcAft>
+              <a:buNone/>
+            </a:pPr>
+            <a:r>
+              <a:rPr lang="en-GB" sz="1600" b="1" dirty="0"/>
+              <a:t>Approach:</a:t>
+            </a:r>
+          </a:p>
+          <a:p>
+            <a:pPr marL="0" indent="0">
+              <a:spcBef>
+                <a:spcPts val="225"/>
+              </a:spcBef>
+              <a:spcAft>
+                <a:spcPts val="225"/>
+              </a:spcAft>
+              <a:buNone/>
+            </a:pPr>
+            <a:r>
+              <a:rPr lang="en-GB" sz="1600" dirty="0"/>
+              <a:t>This draft defines a </a:t>
+            </a:r>
+            <a:r>
+              <a:rPr lang="en-GB" sz="1600" dirty="0">
+                <a:solidFill>
+                  <a:schemeClr val="accent2"/>
+                </a:solidFill>
+              </a:rPr>
+              <a:t>standardized, architecture‑level framework</a:t>
+            </a:r>
+          </a:p>
+          <a:p>
+            <a:pPr marL="0" indent="0">
+              <a:spcBef>
+                <a:spcPts val="225"/>
+              </a:spcBef>
+              <a:spcAft>
+                <a:spcPts val="225"/>
+              </a:spcAft>
+              <a:buNone/>
+            </a:pPr>
+            <a:endParaRPr lang="en-GB" sz="1600" dirty="0">
+              <a:solidFill>
+                <a:schemeClr val="accent2"/>
+              </a:solidFill>
+            </a:endParaRPr>
+          </a:p>
+          <a:p>
+            <a:pPr marL="0" indent="0">
+              <a:spcBef>
+                <a:spcPts val="225"/>
+              </a:spcBef>
+              <a:spcAft>
+                <a:spcPts val="225"/>
+              </a:spcAft>
+              <a:buNone/>
+            </a:pPr>
+            <a:r>
+              <a:rPr lang="en-GB" sz="1600" b="1" dirty="0"/>
+              <a:t>Outcome</a:t>
+            </a:r>
+            <a:r>
+              <a:rPr lang="en-GB" sz="1600" dirty="0"/>
+              <a:t>:</a:t>
+            </a:r>
+          </a:p>
+          <a:p>
+            <a:pPr marL="0" indent="0">
+              <a:spcBef>
+                <a:spcPts val="225"/>
+              </a:spcBef>
+              <a:spcAft>
+                <a:spcPts val="225"/>
+              </a:spcAft>
+              <a:buNone/>
+            </a:pPr>
+            <a:r>
+              <a:rPr lang="en-GB" sz="1600" dirty="0"/>
+              <a:t>Enable </a:t>
+            </a:r>
+            <a:r>
+              <a:rPr lang="en-GB" sz="1600" dirty="0">
+                <a:solidFill>
+                  <a:schemeClr val="accent2"/>
+                </a:solidFill>
+              </a:rPr>
+              <a:t>automated service disruption detection</a:t>
+            </a:r>
+            <a:endParaRPr lang="en-US" sz="1600" dirty="0">
+              <a:solidFill>
+                <a:schemeClr val="accent2"/>
+              </a:solidFill>
+            </a:endParaRPr>
           </a:p>
         </p:txBody>
       </p:sp>
@@ -10679,7 +10996,7 @@
           <p:nvPr/>
         </p:nvPicPr>
         <p:blipFill>
-          <a:blip r:embed="rId2"/>
+          <a:blip r:embed="rId3"/>
           <a:stretch>
             <a:fillRect/>
           </a:stretch>
@@ -10694,35 +11011,6 @@
           </a:prstGeom>
         </p:spPr>
       </p:pic>
-      <p:sp>
-        <p:nvSpPr>
-          <p:cNvPr id="6" name="Date Placeholder 5">
-            <a:extLst>
-              <a:ext uri="{FF2B5EF4-FFF2-40B4-BE49-F238E27FC236}">
-                <a16:creationId xmlns:a16="http://schemas.microsoft.com/office/drawing/2014/main" id="{18EBEDAD-2257-CD00-F5AC-7CB33EC81232}"/>
-              </a:ext>
-            </a:extLst>
-          </p:cNvPr>
-          <p:cNvSpPr>
-            <a:spLocks noGrp="1"/>
-          </p:cNvSpPr>
-          <p:nvPr>
-            <p:ph type="dt" sz="half" idx="10"/>
-          </p:nvPr>
-        </p:nvSpPr>
-        <p:spPr/>
-        <p:txBody>
-          <a:bodyPr/>
-          <a:lstStyle/>
-          <a:p>
-            <a:fld id="{AF901AE6-770F-8841-B36C-9BB82D836878}" type="datetime1">
-              <a:rPr lang="de-CH" smtClean="0"/>
-              <a:t>12.03.26</a:t>
-            </a:fld>
-            <a:endParaRPr lang="en-US"/>
-          </a:p>
-        </p:txBody>
-      </p:sp>
       <p:sp>
         <p:nvSpPr>
           <p:cNvPr id="7" name="Slide Number Placeholder 6">
@@ -10782,7 +11070,7 @@
           <a:p>
             <a:r>
               <a:rPr lang="en-US" sz="800" dirty="0">
-                <a:hlinkClick r:id="rId3"/>
+                <a:hlinkClick r:id="rId4"/>
               </a:rPr>
               <a:t>draft-ietf-nmop-network-anomaly-architecture</a:t>
             </a:r>
@@ -10933,8 +11221,6 @@
               <a:spcAft>
                 <a:spcPts val="225"/>
               </a:spcAft>
-              <a:buFontTx/>
-              <a:buChar char="-"/>
             </a:pPr>
             <a:r>
               <a:rPr lang="en-GB" sz="1400" dirty="0"/>
@@ -11088,35 +11374,6 @@
                 </a:schemeClr>
               </a:solidFill>
             </a:endParaRPr>
-          </a:p>
-        </p:txBody>
-      </p:sp>
-      <p:sp>
-        <p:nvSpPr>
-          <p:cNvPr id="5" name="Date Placeholder 4">
-            <a:extLst>
-              <a:ext uri="{FF2B5EF4-FFF2-40B4-BE49-F238E27FC236}">
-                <a16:creationId xmlns:a16="http://schemas.microsoft.com/office/drawing/2014/main" id="{A0852385-167C-97D4-01A1-E368D5F48EF8}"/>
-              </a:ext>
-            </a:extLst>
-          </p:cNvPr>
-          <p:cNvSpPr>
-            <a:spLocks noGrp="1"/>
-          </p:cNvSpPr>
-          <p:nvPr>
-            <p:ph type="dt" sz="half" idx="10"/>
-          </p:nvPr>
-        </p:nvSpPr>
-        <p:spPr/>
-        <p:txBody>
-          <a:bodyPr/>
-          <a:lstStyle/>
-          <a:p>
-            <a:fld id="{D89484F6-4B41-9E41-A6A3-57B4ED278EE2}" type="datetime1">
-              <a:rPr lang="de-CH" smtClean="0"/>
-              <a:t>12.03.26</a:t>
-            </a:fld>
-            <a:endParaRPr lang="en-US"/>
           </a:p>
         </p:txBody>
       </p:sp>
@@ -11348,35 +11605,6 @@
                 </a:schemeClr>
               </a:solidFill>
             </a:endParaRPr>
-          </a:p>
-        </p:txBody>
-      </p:sp>
-      <p:sp>
-        <p:nvSpPr>
-          <p:cNvPr id="5" name="Date Placeholder 4">
-            <a:extLst>
-              <a:ext uri="{FF2B5EF4-FFF2-40B4-BE49-F238E27FC236}">
-                <a16:creationId xmlns:a16="http://schemas.microsoft.com/office/drawing/2014/main" id="{4BFFDBFA-3D98-B5E4-BA2E-8E40EF0F83C3}"/>
-              </a:ext>
-            </a:extLst>
-          </p:cNvPr>
-          <p:cNvSpPr>
-            <a:spLocks noGrp="1"/>
-          </p:cNvSpPr>
-          <p:nvPr>
-            <p:ph type="dt" sz="half" idx="10"/>
-          </p:nvPr>
-        </p:nvSpPr>
-        <p:spPr/>
-        <p:txBody>
-          <a:bodyPr/>
-          <a:lstStyle/>
-          <a:p>
-            <a:fld id="{424BBBEE-3E14-134E-8436-66BE949C590A}" type="datetime1">
-              <a:rPr lang="de-CH" smtClean="0"/>
-              <a:t>12.03.26</a:t>
-            </a:fld>
-            <a:endParaRPr lang="en-US"/>
           </a:p>
         </p:txBody>
       </p:sp>
@@ -11679,35 +11907,6 @@
                 </a:schemeClr>
               </a:solidFill>
             </a:endParaRPr>
-          </a:p>
-        </p:txBody>
-      </p:sp>
-      <p:sp>
-        <p:nvSpPr>
-          <p:cNvPr id="5" name="Date Placeholder 4">
-            <a:extLst>
-              <a:ext uri="{FF2B5EF4-FFF2-40B4-BE49-F238E27FC236}">
-                <a16:creationId xmlns:a16="http://schemas.microsoft.com/office/drawing/2014/main" id="{6BD0B383-D4F0-71AD-74FD-88C10F7F4C85}"/>
-              </a:ext>
-            </a:extLst>
-          </p:cNvPr>
-          <p:cNvSpPr>
-            <a:spLocks noGrp="1"/>
-          </p:cNvSpPr>
-          <p:nvPr>
-            <p:ph type="dt" sz="half" idx="10"/>
-          </p:nvPr>
-        </p:nvSpPr>
-        <p:spPr/>
-        <p:txBody>
-          <a:bodyPr/>
-          <a:lstStyle/>
-          <a:p>
-            <a:fld id="{424BBBEE-3E14-134E-8436-66BE949C590A}" type="datetime1">
-              <a:rPr lang="de-CH" smtClean="0"/>
-              <a:t>12.03.26</a:t>
-            </a:fld>
-            <a:endParaRPr lang="en-US"/>
           </a:p>
         </p:txBody>
       </p:sp>
@@ -12470,23 +12669,7 @@
           <a:p>
             <a:r>
               <a:rPr lang="en-US" dirty="0"/>
-              <a:t>draft-</a:t>
-            </a:r>
-            <a:r>
-              <a:rPr lang="en-US" dirty="0" err="1"/>
-              <a:t>ietf</a:t>
-            </a:r>
-            <a:r>
-              <a:rPr lang="en-US" dirty="0"/>
-              <a:t>-</a:t>
-            </a:r>
-            <a:r>
-              <a:rPr lang="en-US" dirty="0" err="1"/>
-              <a:t>nmop</a:t>
-            </a:r>
-            <a:r>
-              <a:rPr lang="en-US" dirty="0"/>
-              <a:t>-network-anomaly-semantics</a:t>
+              <a:t>draft-ietf-nmop-network-anomaly-semantics-05</a:t>
             </a:r>
             <a:br>
               <a:rPr lang="en-CH" dirty="0"/>
@@ -12520,35 +12703,6 @@
               <a:rPr lang="en-US" b="1" dirty="0"/>
               <a:t>Semantic Metadata Annotation</a:t>
             </a:r>
-          </a:p>
-        </p:txBody>
-      </p:sp>
-      <p:sp>
-        <p:nvSpPr>
-          <p:cNvPr id="4" name="Date Placeholder 3">
-            <a:extLst>
-              <a:ext uri="{FF2B5EF4-FFF2-40B4-BE49-F238E27FC236}">
-                <a16:creationId xmlns:a16="http://schemas.microsoft.com/office/drawing/2014/main" id="{46AAA0A0-4396-F64B-DC19-BF45F798DEBF}"/>
-              </a:ext>
-            </a:extLst>
-          </p:cNvPr>
-          <p:cNvSpPr>
-            <a:spLocks noGrp="1"/>
-          </p:cNvSpPr>
-          <p:nvPr>
-            <p:ph type="dt" sz="half" idx="10"/>
-          </p:nvPr>
-        </p:nvSpPr>
-        <p:spPr/>
-        <p:txBody>
-          <a:bodyPr/>
-          <a:lstStyle/>
-          <a:p>
-            <a:fld id="{FEC2240F-8AA3-2746-9A51-9D1A136F1E49}" type="datetime1">
-              <a:rPr lang="de-CH" smtClean="0"/>
-              <a:t>12.03.26</a:t>
-            </a:fld>
-            <a:endParaRPr lang="en-US"/>
           </a:p>
         </p:txBody>
       </p:sp>
@@ -12698,8 +12852,8 @@
         </p:nvSpPr>
         <p:spPr>
           <a:xfrm>
-            <a:off x="576000" y="2160000"/>
-            <a:ext cx="3634050" cy="1914262"/>
+            <a:off x="720000" y="1800000"/>
+            <a:ext cx="3634050" cy="4254000"/>
           </a:xfrm>
           <a:prstGeom prst="rect">
             <a:avLst/>
@@ -12851,102 +13005,128 @@
               <a:buNone/>
             </a:pPr>
             <a:r>
+              <a:rPr lang="en-GB" sz="1600" b="1" dirty="0"/>
+              <a:t>Motivation:</a:t>
+            </a:r>
+          </a:p>
+          <a:p>
+            <a:pPr marL="0" indent="0">
+              <a:buNone/>
+            </a:pPr>
+            <a:r>
+              <a:rPr lang="en-GB" sz="1600" dirty="0"/>
+              <a:t>Enable the </a:t>
+            </a:r>
+            <a:r>
               <a:rPr lang="en-GB" sz="1600" dirty="0">
                 <a:solidFill>
-                  <a:srgbClr val="FF0000"/>
-                </a:solidFill>
-              </a:rPr>
-              <a:t>To facilitate the </a:t>
-            </a:r>
-            <a:r>
-              <a:rPr lang="en-GB" sz="1600" b="1" dirty="0">
-                <a:solidFill>
-                  <a:srgbClr val="FF0000"/>
+                  <a:schemeClr val="accent2"/>
                 </a:solidFill>
               </a:rPr>
               <a:t>exchange</a:t>
             </a:r>
             <a:r>
+              <a:rPr lang="en-GB" sz="1600" dirty="0"/>
+              <a:t> of network anomaly data across diverse systems and support </a:t>
+            </a:r>
+            <a:r>
               <a:rPr lang="en-GB" sz="1600" dirty="0">
                 <a:solidFill>
-                  <a:srgbClr val="FF0000"/>
-                </a:solidFill>
-              </a:rPr>
-              <a:t> of network anomaly data across diverse systems, and </a:t>
-            </a:r>
-            <a:r>
-              <a:rPr lang="en-GB" sz="1600" b="1" dirty="0">
-                <a:solidFill>
-                  <a:srgbClr val="FF0000"/>
+                  <a:schemeClr val="accent2"/>
                 </a:solidFill>
               </a:rPr>
               <a:t>benchmarking</a:t>
             </a:r>
             <a:r>
+              <a:rPr lang="en-GB" sz="1600" dirty="0"/>
+              <a:t> of anomaly detection solutions</a:t>
+            </a:r>
+          </a:p>
+          <a:p>
+            <a:pPr marL="0" indent="0">
+              <a:buNone/>
+            </a:pPr>
+            <a:endParaRPr lang="en-GB" sz="1600" dirty="0"/>
+          </a:p>
+          <a:p>
+            <a:pPr marL="0" indent="0">
+              <a:buNone/>
+            </a:pPr>
+            <a:r>
+              <a:rPr lang="en-GB" sz="1600" b="1" dirty="0"/>
+              <a:t>Approach:</a:t>
+            </a:r>
+          </a:p>
+          <a:p>
+            <a:pPr marL="0" indent="0">
+              <a:buNone/>
+            </a:pPr>
+            <a:r>
+              <a:rPr lang="en-GB" sz="1600" dirty="0"/>
+              <a:t>Define a </a:t>
+            </a:r>
+            <a:r>
               <a:rPr lang="en-GB" sz="1600" dirty="0">
                 <a:solidFill>
-                  <a:srgbClr val="FF0000"/>
-                </a:solidFill>
-              </a:rPr>
-              <a:t> of various anomaly detection systems</a:t>
+                  <a:schemeClr val="accent2"/>
+                </a:solidFill>
+              </a:rPr>
+              <a:t>standardized semantic metadata schema</a:t>
             </a:r>
             <a:r>
               <a:rPr lang="en-GB" sz="1600" dirty="0"/>
-              <a:t>, this draft defines a </a:t>
-            </a:r>
+              <a:t> and a set of </a:t>
+            </a:r>
+            <a:r>
+              <a:rPr lang="en-GB" sz="1600" dirty="0">
+                <a:solidFill>
+                  <a:schemeClr val="accent2"/>
+                </a:solidFill>
+              </a:rPr>
+              <a:t>semantically structured terms</a:t>
+            </a:r>
+          </a:p>
+          <a:p>
+            <a:pPr marL="0" indent="0">
+              <a:buNone/>
+            </a:pPr>
+            <a:endParaRPr lang="en-GB" sz="1600" dirty="0"/>
+          </a:p>
+          <a:p>
+            <a:pPr marL="0" indent="0">
+              <a:buNone/>
+            </a:pPr>
             <a:r>
               <a:rPr lang="en-GB" sz="1600" b="1" dirty="0"/>
-              <a:t>standardized semantic metadata schema </a:t>
-            </a:r>
+              <a:t>Outcome:</a:t>
+            </a:r>
+          </a:p>
+          <a:p>
+            <a:pPr marL="0" indent="0">
+              <a:buNone/>
+            </a:pPr>
             <a:r>
               <a:rPr lang="en-GB" sz="1600" dirty="0"/>
-              <a:t>and</a:t>
-            </a:r>
-            <a:r>
-              <a:rPr lang="en-GB" sz="1600" b="1" dirty="0"/>
-              <a:t> </a:t>
+              <a:t>Provide </a:t>
+            </a:r>
+            <a:r>
+              <a:rPr lang="en-GB" sz="1600" dirty="0">
+                <a:solidFill>
+                  <a:schemeClr val="accent2"/>
+                </a:solidFill>
+              </a:rPr>
+              <a:t>human‑readable context </a:t>
             </a:r>
             <a:r>
               <a:rPr lang="en-GB" sz="1600" dirty="0"/>
-              <a:t>a set of </a:t>
-            </a:r>
-            <a:r>
-              <a:rPr lang="en-GB" sz="1600" b="1" dirty="0"/>
-              <a:t>semantically structured terms </a:t>
-            </a:r>
-            <a:r>
-              <a:rPr lang="en-GB" sz="1600" dirty="0"/>
-              <a:t>that provide human-readable context for network anomalies.</a:t>
-            </a:r>
-          </a:p>
-        </p:txBody>
-      </p:sp>
-      <p:sp>
-        <p:nvSpPr>
-          <p:cNvPr id="3" name="Date Placeholder 2">
-            <a:extLst>
-              <a:ext uri="{FF2B5EF4-FFF2-40B4-BE49-F238E27FC236}">
-                <a16:creationId xmlns:a16="http://schemas.microsoft.com/office/drawing/2014/main" id="{9A9466B9-3DA5-632F-C775-71971A1A8ECA}"/>
-              </a:ext>
-            </a:extLst>
-          </p:cNvPr>
-          <p:cNvSpPr>
-            <a:spLocks noGrp="1"/>
-          </p:cNvSpPr>
-          <p:nvPr>
-            <p:ph type="dt" sz="half" idx="10"/>
-          </p:nvPr>
-        </p:nvSpPr>
-        <p:spPr/>
-        <p:txBody>
-          <a:bodyPr/>
-          <a:lstStyle/>
-          <a:p>
-            <a:fld id="{0772E8C7-46E4-2945-98F0-FAB6CBA5DC8E}" type="datetime1">
-              <a:rPr lang="de-CH" smtClean="0"/>
-              <a:t>12.03.26</a:t>
-            </a:fld>
-            <a:endParaRPr lang="en-US"/>
+              <a:t>for describing and understanding network anomalies</a:t>
+            </a:r>
+          </a:p>
+          <a:p>
+            <a:pPr marL="0" indent="0">
+              <a:buNone/>
+            </a:pPr>
+            <a:endParaRPr lang="en-GB" sz="1600" dirty="0"/>
           </a:p>
         </p:txBody>
       </p:sp>
@@ -13001,7 +13181,7 @@
         </p:blipFill>
         <p:spPr>
           <a:xfrm>
-            <a:off x="4933952" y="2002706"/>
+            <a:off x="4879975" y="2314575"/>
             <a:ext cx="3346450" cy="2228850"/>
           </a:xfrm>
           <a:prstGeom prst="rect">

</xml_diff>